<commit_message>
fix(chart): a scatter or bubble with no X values is rebuilt where PowerPoint plots it
A series with no `c:xVal` came back from the script converter with an empty X row. PowerPoint plots
such a series at X = 1..n, but `addChart` sizes every series by the X row, so the rebuilt chart
plotted no point at all. It is now rebuilt against 1..n, as a series against text X labels already
was.

That rebuild was proven for a scatter only. A bubble takes the same `c:xVal`, and exported over COM,
a bubble against text, a bubble with no X column and a scatter with no X column each render
pixel-identical to the same values at X = 1..4, while controls at X = 2..5 do not.

`chart-series-shapes.pptx` gains the three as slides 6 to 8. `SetSourceData` over a text column A
does not build the text-X bubble, so the recipe sources that chart from its Y and size columns and
assigns the X range to its series afterwards.
</commit_message>
<xml_diff>
--- a/test/read/fixtures/chart-series-shapes.pptx
+++ b/test/read/fixtures/chart-series-shapes.pptx
@@ -10,6 +10,9 @@
     <p:sldId id="258" r:id="rId4"/>
     <p:sldId id="259" r:id="rId5"/>
     <p:sldId id="260" r:id="rId6"/>
+    <p:sldId id="261" r:id="rId7"/>
+    <p:sldId id="262" r:id="rId8"/>
+    <p:sldId id="263" r:id="rId9"/>
   </p:sldIdLst>
   <p:sldSz cx="12192000" cy="6858000"/>
   <p:notesSz cx="6858000" cy="9144000"/>
@@ -242,7 +245,7 @@
           <c:smooth val="0"/>
           <c:extLst>
             <c:ext xmlns:c16="http://schemas.microsoft.com/office/drawing/2014/chart" uri="{C3380CC4-5D6E-409C-BE32-E72D297353CC}">
-              <c16:uniqueId val="{00000000-3C3F-46FA-B913-D339ED9BAFA4}"/>
+              <c16:uniqueId val="{00000000-B2BD-4552-8F79-D20DB4341F15}"/>
             </c:ext>
           </c:extLst>
         </c:ser>
@@ -254,11 +257,11 @@
           <c:showPercent val="0"/>
           <c:showBubbleSize val="0"/>
         </c:dLbls>
-        <c:axId val="1803541887"/>
-        <c:axId val="1660399183"/>
+        <c:axId val="689943888"/>
+        <c:axId val="627182255"/>
       </c:scatterChart>
       <c:valAx>
-        <c:axId val="1803541887"/>
+        <c:axId val="689943888"/>
         <c:scaling>
           <c:orientation val="minMax"/>
         </c:scaling>
@@ -315,12 +318,12 @@
             <a:endParaRPr lang="en-US"/>
           </a:p>
         </c:txPr>
-        <c:crossAx val="1660399183"/>
+        <c:crossAx val="627182255"/>
         <c:crosses val="autoZero"/>
         <c:crossBetween val="midCat"/>
       </c:valAx>
       <c:valAx>
-        <c:axId val="1660399183"/>
+        <c:axId val="627182255"/>
         <c:scaling>
           <c:orientation val="minMax"/>
         </c:scaling>
@@ -377,7 +380,7 @@
             <a:endParaRPr lang="en-US"/>
           </a:p>
         </c:txPr>
-        <c:crossAx val="1803541887"/>
+        <c:crossAx val="689943888"/>
         <c:crosses val="autoZero"/>
         <c:crossBetween val="midCat"/>
       </c:valAx>
@@ -554,7 +557,7 @@
           <c:bubble3D val="0"/>
           <c:extLst>
             <c:ext xmlns:c16="http://schemas.microsoft.com/office/drawing/2014/chart" uri="{C3380CC4-5D6E-409C-BE32-E72D297353CC}">
-              <c16:uniqueId val="{00000000-8CED-42FA-B962-B0F33FCFAC4C}"/>
+              <c16:uniqueId val="{00000000-6B08-4669-A1D0-CA2080528608}"/>
             </c:ext>
           </c:extLst>
         </c:ser>
@@ -568,11 +571,11 @@
         </c:dLbls>
         <c:bubbleScale val="100"/>
         <c:showNegBubbles val="0"/>
-        <c:axId val="1803534927"/>
-        <c:axId val="1660378063"/>
+        <c:axId val="689948064"/>
+        <c:axId val="486069391"/>
       </c:bubbleChart>
       <c:valAx>
-        <c:axId val="1803534927"/>
+        <c:axId val="689948064"/>
         <c:scaling>
           <c:orientation val="minMax"/>
         </c:scaling>
@@ -629,12 +632,12 @@
             <a:endParaRPr lang="en-US"/>
           </a:p>
         </c:txPr>
-        <c:crossAx val="1660378063"/>
+        <c:crossAx val="486069391"/>
         <c:crosses val="autoZero"/>
         <c:crossBetween val="midCat"/>
       </c:valAx>
       <c:valAx>
-        <c:axId val="1660378063"/>
+        <c:axId val="486069391"/>
         <c:scaling>
           <c:orientation val="minMax"/>
         </c:scaling>
@@ -691,7 +694,7 @@
             <a:endParaRPr lang="en-US"/>
           </a:p>
         </c:txPr>
-        <c:crossAx val="1803534927"/>
+        <c:crossAx val="689948064"/>
         <c:crosses val="autoZero"/>
         <c:crossBetween val="midCat"/>
       </c:valAx>
@@ -866,7 +869,7 @@
           </c:val>
           <c:extLst>
             <c:ext xmlns:c16="http://schemas.microsoft.com/office/drawing/2014/chart" uri="{C3380CC4-5D6E-409C-BE32-E72D297353CC}">
-              <c16:uniqueId val="{00000000-60DD-4F65-9D1E-DC146C9BC936}"/>
+              <c16:uniqueId val="{00000000-D4DB-4845-AD5B-CFE5AED05C7C}"/>
             </c:ext>
           </c:extLst>
         </c:ser>
@@ -880,11 +883,11 @@
         </c:dLbls>
         <c:gapWidth val="219"/>
         <c:overlap val="-27"/>
-        <c:axId val="1502869855"/>
-        <c:axId val="1660364623"/>
+        <c:axId val="568321935"/>
+        <c:axId val="486073231"/>
       </c:barChart>
       <c:catAx>
-        <c:axId val="1502869855"/>
+        <c:axId val="568321935"/>
         <c:scaling>
           <c:orientation val="minMax"/>
         </c:scaling>
@@ -927,7 +930,7 @@
             <a:endParaRPr lang="en-US"/>
           </a:p>
         </c:txPr>
-        <c:crossAx val="1660364623"/>
+        <c:crossAx val="486073231"/>
         <c:crosses val="autoZero"/>
         <c:auto val="1"/>
         <c:lblAlgn val="ctr"/>
@@ -935,7 +938,7 @@
         <c:noMultiLvlLbl val="0"/>
       </c:catAx>
       <c:valAx>
-        <c:axId val="1660364623"/>
+        <c:axId val="486073231"/>
         <c:scaling>
           <c:orientation val="minMax"/>
         </c:scaling>
@@ -986,7 +989,7 @@
             <a:endParaRPr lang="en-US"/>
           </a:p>
         </c:txPr>
-        <c:crossAx val="1502869855"/>
+        <c:crossAx val="568321935"/>
         <c:crosses val="autoZero"/>
         <c:crossBetween val="between"/>
       </c:valAx>
@@ -1240,7 +1243,7 @@
           </c:val>
           <c:extLst>
             <c:ext xmlns:c16="http://schemas.microsoft.com/office/drawing/2014/chart" uri="{C3380CC4-5D6E-409C-BE32-E72D297353CC}">
-              <c16:uniqueId val="{00000000-6344-4897-808C-9380B78A8017}"/>
+              <c16:uniqueId val="{00000000-4C45-417A-8A5F-ACFAA846C873}"/>
             </c:ext>
           </c:extLst>
         </c:ser>
@@ -1428,7 +1431,7 @@
           <c:smooth val="0"/>
           <c:extLst>
             <c:ext xmlns:c16="http://schemas.microsoft.com/office/drawing/2014/chart" uri="{C3380CC4-5D6E-409C-BE32-E72D297353CC}">
-              <c16:uniqueId val="{00000000-3A6D-46B9-900F-52E2EFBC9691}"/>
+              <c16:uniqueId val="{00000000-D9E6-44A5-AD44-BBF419C0912C}"/>
             </c:ext>
           </c:extLst>
         </c:ser>
@@ -1440,11 +1443,11 @@
           <c:showPercent val="0"/>
           <c:showBubbleSize val="0"/>
         </c:dLbls>
-        <c:axId val="1803519615"/>
-        <c:axId val="1660358383"/>
+        <c:axId val="689941568"/>
+        <c:axId val="486075151"/>
       </c:scatterChart>
       <c:valAx>
-        <c:axId val="1803519615"/>
+        <c:axId val="689941568"/>
         <c:scaling>
           <c:orientation val="minMax"/>
         </c:scaling>
@@ -1500,12 +1503,12 @@
             <a:endParaRPr lang="en-US"/>
           </a:p>
         </c:txPr>
-        <c:crossAx val="1660358383"/>
+        <c:crossAx val="486075151"/>
         <c:crosses val="autoZero"/>
         <c:crossBetween val="midCat"/>
       </c:valAx>
       <c:valAx>
-        <c:axId val="1660358383"/>
+        <c:axId val="486075151"/>
         <c:scaling>
           <c:orientation val="minMax"/>
         </c:scaling>
@@ -1562,7 +1565,902 @@
             <a:endParaRPr lang="en-US"/>
           </a:p>
         </c:txPr>
-        <c:crossAx val="1803519615"/>
+        <c:crossAx val="689941568"/>
+        <c:crosses val="autoZero"/>
+        <c:crossBetween val="midCat"/>
+      </c:valAx>
+      <c:spPr>
+        <a:noFill/>
+        <a:ln>
+          <a:noFill/>
+        </a:ln>
+        <a:effectLst/>
+      </c:spPr>
+    </c:plotArea>
+    <c:legend>
+      <c:legendPos val="b"/>
+      <c:overlay val="0"/>
+      <c:spPr>
+        <a:noFill/>
+        <a:ln>
+          <a:noFill/>
+        </a:ln>
+        <a:effectLst/>
+      </c:spPr>
+      <c:txPr>
+        <a:bodyPr rot="0" spcFirstLastPara="1" vertOverflow="ellipsis" vert="horz" wrap="square" anchor="ctr" anchorCtr="1"/>
+        <a:lstStyle/>
+        <a:p>
+          <a:pPr>
+            <a:defRPr sz="1197" b="0" i="0" u="none" strike="noStrike" kern="1200" baseline="0">
+              <a:solidFill>
+                <a:schemeClr val="tx1">
+                  <a:lumMod val="65000"/>
+                  <a:lumOff val="35000"/>
+                </a:schemeClr>
+              </a:solidFill>
+              <a:latin typeface="+mn-lt"/>
+              <a:ea typeface="+mn-ea"/>
+              <a:cs typeface="+mn-cs"/>
+            </a:defRPr>
+          </a:pPr>
+          <a:endParaRPr lang="en-US"/>
+        </a:p>
+      </c:txPr>
+    </c:legend>
+    <c:plotVisOnly val="1"/>
+    <c:dispBlanksAs val="gap"/>
+    <c:showDLblsOverMax val="0"/>
+    <c:extLst>
+      <c:ext xmlns:c16r3="http://schemas.microsoft.com/office/drawing/2017/03/chart" uri="{56B9EC1D-385E-4148-901F-78D8002777C0}">
+        <c16r3:dataDisplayOptions16>
+          <c16r3:dispNaAsBlank val="1"/>
+        </c16r3:dataDisplayOptions16>
+      </c:ext>
+    </c:extLst>
+  </c:chart>
+  <c:spPr>
+    <a:noFill/>
+    <a:ln>
+      <a:noFill/>
+    </a:ln>
+    <a:effectLst/>
+  </c:spPr>
+  <c:txPr>
+    <a:bodyPr/>
+    <a:lstStyle/>
+    <a:p>
+      <a:pPr>
+        <a:defRPr/>
+      </a:pPr>
+      <a:endParaRPr lang="en-US"/>
+    </a:p>
+  </c:txPr>
+  <c:externalData r:id="rId3">
+    <c:autoUpdate val="0"/>
+  </c:externalData>
+</c:chartSpace>
+</file>
+
+<file path=ppt/charts/chart6.xml><?xml version="1.0" encoding="utf-8"?>
+<c:chartSpace xmlns:c="http://schemas.openxmlformats.org/drawingml/2006/chart" xmlns:a="http://schemas.openxmlformats.org/drawingml/2006/main" xmlns:r="http://schemas.openxmlformats.org/officeDocument/2006/relationships" xmlns:c16r2="http://schemas.microsoft.com/office/drawing/2015/06/chart">
+  <c:date1904 val="0"/>
+  <c:lang val="en-US"/>
+  <c:roundedCorners val="0"/>
+  <mc:AlternateContent xmlns:mc="http://schemas.openxmlformats.org/markup-compatibility/2006">
+    <mc:Choice xmlns:c14="http://schemas.microsoft.com/office/drawing/2007/8/2/chart" Requires="c14">
+      <c14:style val="102"/>
+    </mc:Choice>
+    <mc:Fallback>
+      <c:style val="2"/>
+    </mc:Fallback>
+  </mc:AlternateContent>
+  <c:chart>
+    <c:autoTitleDeleted val="0"/>
+    <c:plotArea>
+      <c:layout/>
+      <c:bubbleChart>
+        <c:varyColors val="0"/>
+        <c:ser>
+          <c:idx val="0"/>
+          <c:order val="0"/>
+          <c:spPr>
+            <a:solidFill>
+              <a:schemeClr val="accent1">
+                <a:alpha val="75000"/>
+              </a:schemeClr>
+            </a:solidFill>
+            <a:ln>
+              <a:noFill/>
+            </a:ln>
+            <a:effectLst/>
+          </c:spPr>
+          <c:invertIfNegative val="0"/>
+          <c:xVal>
+            <c:strRef>
+              <c:f>Sheet1!$A$2:$A$5</c:f>
+              <c:strCache>
+                <c:ptCount val="4"/>
+                <c:pt idx="0">
+                  <c:v>2023</c:v>
+                </c:pt>
+                <c:pt idx="1">
+                  <c:v>2024</c:v>
+                </c:pt>
+                <c:pt idx="2">
+                  <c:v>2025</c:v>
+                </c:pt>
+                <c:pt idx="3">
+                  <c:v>2026e</c:v>
+                </c:pt>
+              </c:strCache>
+            </c:strRef>
+          </c:xVal>
+          <c:yVal>
+            <c:numRef>
+              <c:f>Sheet1!$B$2:$B$5</c:f>
+              <c:numCache>
+                <c:formatCode>General</c:formatCode>
+                <c:ptCount val="4"/>
+                <c:pt idx="0">
+                  <c:v>2</c:v>
+                </c:pt>
+                <c:pt idx="1">
+                  <c:v>4</c:v>
+                </c:pt>
+                <c:pt idx="2">
+                  <c:v>3</c:v>
+                </c:pt>
+                <c:pt idx="3">
+                  <c:v>6</c:v>
+                </c:pt>
+              </c:numCache>
+            </c:numRef>
+          </c:yVal>
+          <c:bubbleSize>
+            <c:numRef>
+              <c:f>Sheet1!$C$2:$C$5</c:f>
+              <c:numCache>
+                <c:formatCode>General</c:formatCode>
+                <c:ptCount val="4"/>
+                <c:pt idx="0">
+                  <c:v>5</c:v>
+                </c:pt>
+                <c:pt idx="1">
+                  <c:v>10</c:v>
+                </c:pt>
+                <c:pt idx="2">
+                  <c:v>7</c:v>
+                </c:pt>
+                <c:pt idx="3">
+                  <c:v>12</c:v>
+                </c:pt>
+              </c:numCache>
+            </c:numRef>
+          </c:bubbleSize>
+          <c:bubble3D val="0"/>
+          <c:extLst>
+            <c:ext xmlns:c16="http://schemas.microsoft.com/office/drawing/2014/chart" uri="{C3380CC4-5D6E-409C-BE32-E72D297353CC}">
+              <c16:uniqueId val="{00000000-1926-4F51-A116-2FE301A25207}"/>
+            </c:ext>
+          </c:extLst>
+        </c:ser>
+        <c:dLbls>
+          <c:showLegendKey val="0"/>
+          <c:showVal val="0"/>
+          <c:showCatName val="0"/>
+          <c:showSerName val="0"/>
+          <c:showPercent val="0"/>
+          <c:showBubbleSize val="0"/>
+        </c:dLbls>
+        <c:bubbleScale val="100"/>
+        <c:showNegBubbles val="0"/>
+        <c:axId val="689940176"/>
+        <c:axId val="486095791"/>
+      </c:bubbleChart>
+      <c:valAx>
+        <c:axId val="689940176"/>
+        <c:scaling>
+          <c:orientation val="minMax"/>
+        </c:scaling>
+        <c:delete val="0"/>
+        <c:axPos val="b"/>
+        <c:majorGridlines>
+          <c:spPr>
+            <a:ln w="9525" cap="flat" cmpd="sng" algn="ctr">
+              <a:solidFill>
+                <a:schemeClr val="tx1">
+                  <a:lumMod val="15000"/>
+                  <a:lumOff val="85000"/>
+                </a:schemeClr>
+              </a:solidFill>
+              <a:round/>
+            </a:ln>
+            <a:effectLst/>
+          </c:spPr>
+        </c:majorGridlines>
+        <c:majorTickMark val="none"/>
+        <c:minorTickMark val="none"/>
+        <c:tickLblPos val="nextTo"/>
+        <c:spPr>
+          <a:noFill/>
+          <a:ln w="9525" cap="flat" cmpd="sng" algn="ctr">
+            <a:solidFill>
+              <a:schemeClr val="tx1">
+                <a:lumMod val="25000"/>
+                <a:lumOff val="75000"/>
+              </a:schemeClr>
+            </a:solidFill>
+            <a:round/>
+          </a:ln>
+          <a:effectLst/>
+        </c:spPr>
+        <c:txPr>
+          <a:bodyPr rot="-60000000" spcFirstLastPara="1" vertOverflow="ellipsis" vert="horz" wrap="square" anchor="ctr" anchorCtr="1"/>
+          <a:lstStyle/>
+          <a:p>
+            <a:pPr>
+              <a:defRPr sz="1197" b="0" i="0" u="none" strike="noStrike" kern="1200" baseline="0">
+                <a:solidFill>
+                  <a:schemeClr val="tx1">
+                    <a:lumMod val="65000"/>
+                    <a:lumOff val="35000"/>
+                  </a:schemeClr>
+                </a:solidFill>
+                <a:latin typeface="+mn-lt"/>
+                <a:ea typeface="+mn-ea"/>
+                <a:cs typeface="+mn-cs"/>
+              </a:defRPr>
+            </a:pPr>
+            <a:endParaRPr lang="en-US"/>
+          </a:p>
+        </c:txPr>
+        <c:crossAx val="486095791"/>
+        <c:crosses val="autoZero"/>
+        <c:crossBetween val="midCat"/>
+      </c:valAx>
+      <c:valAx>
+        <c:axId val="486095791"/>
+        <c:scaling>
+          <c:orientation val="minMax"/>
+        </c:scaling>
+        <c:delete val="0"/>
+        <c:axPos val="l"/>
+        <c:majorGridlines>
+          <c:spPr>
+            <a:ln w="9525" cap="flat" cmpd="sng" algn="ctr">
+              <a:solidFill>
+                <a:schemeClr val="tx1">
+                  <a:lumMod val="15000"/>
+                  <a:lumOff val="85000"/>
+                </a:schemeClr>
+              </a:solidFill>
+              <a:round/>
+            </a:ln>
+            <a:effectLst/>
+          </c:spPr>
+        </c:majorGridlines>
+        <c:numFmt formatCode="General" sourceLinked="1"/>
+        <c:majorTickMark val="none"/>
+        <c:minorTickMark val="none"/>
+        <c:tickLblPos val="nextTo"/>
+        <c:spPr>
+          <a:noFill/>
+          <a:ln w="9525" cap="flat" cmpd="sng" algn="ctr">
+            <a:solidFill>
+              <a:schemeClr val="tx1">
+                <a:lumMod val="25000"/>
+                <a:lumOff val="75000"/>
+              </a:schemeClr>
+            </a:solidFill>
+            <a:round/>
+          </a:ln>
+          <a:effectLst/>
+        </c:spPr>
+        <c:txPr>
+          <a:bodyPr rot="-60000000" spcFirstLastPara="1" vertOverflow="ellipsis" vert="horz" wrap="square" anchor="ctr" anchorCtr="1"/>
+          <a:lstStyle/>
+          <a:p>
+            <a:pPr>
+              <a:defRPr sz="1197" b="0" i="0" u="none" strike="noStrike" kern="1200" baseline="0">
+                <a:solidFill>
+                  <a:schemeClr val="tx1">
+                    <a:lumMod val="65000"/>
+                    <a:lumOff val="35000"/>
+                  </a:schemeClr>
+                </a:solidFill>
+                <a:latin typeface="+mn-lt"/>
+                <a:ea typeface="+mn-ea"/>
+                <a:cs typeface="+mn-cs"/>
+              </a:defRPr>
+            </a:pPr>
+            <a:endParaRPr lang="en-US"/>
+          </a:p>
+        </c:txPr>
+        <c:crossAx val="689940176"/>
+        <c:crosses val="autoZero"/>
+        <c:crossBetween val="midCat"/>
+      </c:valAx>
+      <c:spPr>
+        <a:noFill/>
+        <a:ln>
+          <a:noFill/>
+        </a:ln>
+        <a:effectLst/>
+      </c:spPr>
+    </c:plotArea>
+    <c:legend>
+      <c:legendPos val="b"/>
+      <c:overlay val="0"/>
+      <c:spPr>
+        <a:noFill/>
+        <a:ln>
+          <a:noFill/>
+        </a:ln>
+        <a:effectLst/>
+      </c:spPr>
+      <c:txPr>
+        <a:bodyPr rot="0" spcFirstLastPara="1" vertOverflow="ellipsis" vert="horz" wrap="square" anchor="ctr" anchorCtr="1"/>
+        <a:lstStyle/>
+        <a:p>
+          <a:pPr>
+            <a:defRPr sz="1197" b="0" i="0" u="none" strike="noStrike" kern="1200" baseline="0">
+              <a:solidFill>
+                <a:schemeClr val="tx1">
+                  <a:lumMod val="65000"/>
+                  <a:lumOff val="35000"/>
+                </a:schemeClr>
+              </a:solidFill>
+              <a:latin typeface="+mn-lt"/>
+              <a:ea typeface="+mn-ea"/>
+              <a:cs typeface="+mn-cs"/>
+            </a:defRPr>
+          </a:pPr>
+          <a:endParaRPr lang="en-US"/>
+        </a:p>
+      </c:txPr>
+    </c:legend>
+    <c:plotVisOnly val="1"/>
+    <c:dispBlanksAs val="gap"/>
+    <c:showDLblsOverMax val="0"/>
+    <c:extLst>
+      <c:ext xmlns:c16r3="http://schemas.microsoft.com/office/drawing/2017/03/chart" uri="{56B9EC1D-385E-4148-901F-78D8002777C0}">
+        <c16r3:dataDisplayOptions16>
+          <c16r3:dispNaAsBlank val="1"/>
+        </c16r3:dataDisplayOptions16>
+      </c:ext>
+    </c:extLst>
+  </c:chart>
+  <c:spPr>
+    <a:noFill/>
+    <a:ln>
+      <a:noFill/>
+    </a:ln>
+    <a:effectLst/>
+  </c:spPr>
+  <c:txPr>
+    <a:bodyPr/>
+    <a:lstStyle/>
+    <a:p>
+      <a:pPr>
+        <a:defRPr/>
+      </a:pPr>
+      <a:endParaRPr lang="en-US"/>
+    </a:p>
+  </c:txPr>
+  <c:externalData r:id="rId3">
+    <c:autoUpdate val="0"/>
+  </c:externalData>
+</c:chartSpace>
+</file>
+
+<file path=ppt/charts/chart7.xml><?xml version="1.0" encoding="utf-8"?>
+<c:chartSpace xmlns:c="http://schemas.openxmlformats.org/drawingml/2006/chart" xmlns:a="http://schemas.openxmlformats.org/drawingml/2006/main" xmlns:r="http://schemas.openxmlformats.org/officeDocument/2006/relationships" xmlns:c16r2="http://schemas.microsoft.com/office/drawing/2015/06/chart">
+  <c:date1904 val="0"/>
+  <c:lang val="en-US"/>
+  <c:roundedCorners val="0"/>
+  <mc:AlternateContent xmlns:mc="http://schemas.openxmlformats.org/markup-compatibility/2006">
+    <mc:Choice xmlns:c14="http://schemas.microsoft.com/office/drawing/2007/8/2/chart" Requires="c14">
+      <c14:style val="102"/>
+    </mc:Choice>
+    <mc:Fallback>
+      <c:style val="2"/>
+    </mc:Fallback>
+  </mc:AlternateContent>
+  <c:chart>
+    <c:autoTitleDeleted val="0"/>
+    <c:plotArea>
+      <c:layout/>
+      <c:bubbleChart>
+        <c:varyColors val="0"/>
+        <c:ser>
+          <c:idx val="0"/>
+          <c:order val="0"/>
+          <c:spPr>
+            <a:solidFill>
+              <a:schemeClr val="accent1">
+                <a:alpha val="75000"/>
+              </a:schemeClr>
+            </a:solidFill>
+            <a:ln>
+              <a:noFill/>
+            </a:ln>
+            <a:effectLst/>
+          </c:spPr>
+          <c:invertIfNegative val="0"/>
+          <c:yVal>
+            <c:numRef>
+              <c:f>Sheet1!$B$2:$B$5</c:f>
+              <c:numCache>
+                <c:formatCode>General</c:formatCode>
+                <c:ptCount val="4"/>
+                <c:pt idx="0">
+                  <c:v>2</c:v>
+                </c:pt>
+                <c:pt idx="1">
+                  <c:v>4</c:v>
+                </c:pt>
+                <c:pt idx="2">
+                  <c:v>3</c:v>
+                </c:pt>
+                <c:pt idx="3">
+                  <c:v>6</c:v>
+                </c:pt>
+              </c:numCache>
+            </c:numRef>
+          </c:yVal>
+          <c:bubbleSize>
+            <c:numRef>
+              <c:f>Sheet1!$C$2:$C$5</c:f>
+              <c:numCache>
+                <c:formatCode>General</c:formatCode>
+                <c:ptCount val="4"/>
+                <c:pt idx="0">
+                  <c:v>5</c:v>
+                </c:pt>
+                <c:pt idx="1">
+                  <c:v>10</c:v>
+                </c:pt>
+                <c:pt idx="2">
+                  <c:v>7</c:v>
+                </c:pt>
+                <c:pt idx="3">
+                  <c:v>12</c:v>
+                </c:pt>
+              </c:numCache>
+            </c:numRef>
+          </c:bubbleSize>
+          <c:bubble3D val="0"/>
+          <c:extLst>
+            <c:ext xmlns:c16="http://schemas.microsoft.com/office/drawing/2014/chart" uri="{C3380CC4-5D6E-409C-BE32-E72D297353CC}">
+              <c16:uniqueId val="{00000000-4CCE-4EA7-90CD-C5B63279C85C}"/>
+            </c:ext>
+          </c:extLst>
+        </c:ser>
+        <c:dLbls>
+          <c:showLegendKey val="0"/>
+          <c:showVal val="0"/>
+          <c:showCatName val="0"/>
+          <c:showSerName val="0"/>
+          <c:showPercent val="0"/>
+          <c:showBubbleSize val="0"/>
+        </c:dLbls>
+        <c:bubbleScale val="100"/>
+        <c:showNegBubbles val="0"/>
+        <c:axId val="689937856"/>
+        <c:axId val="486096271"/>
+      </c:bubbleChart>
+      <c:valAx>
+        <c:axId val="689937856"/>
+        <c:scaling>
+          <c:orientation val="minMax"/>
+        </c:scaling>
+        <c:delete val="0"/>
+        <c:axPos val="b"/>
+        <c:majorGridlines>
+          <c:spPr>
+            <a:ln w="9525" cap="flat" cmpd="sng" algn="ctr">
+              <a:solidFill>
+                <a:schemeClr val="tx1">
+                  <a:lumMod val="15000"/>
+                  <a:lumOff val="85000"/>
+                </a:schemeClr>
+              </a:solidFill>
+              <a:round/>
+            </a:ln>
+            <a:effectLst/>
+          </c:spPr>
+        </c:majorGridlines>
+        <c:majorTickMark val="none"/>
+        <c:minorTickMark val="none"/>
+        <c:tickLblPos val="nextTo"/>
+        <c:spPr>
+          <a:noFill/>
+          <a:ln w="9525" cap="flat" cmpd="sng" algn="ctr">
+            <a:solidFill>
+              <a:schemeClr val="tx1">
+                <a:lumMod val="25000"/>
+                <a:lumOff val="75000"/>
+              </a:schemeClr>
+            </a:solidFill>
+            <a:round/>
+          </a:ln>
+          <a:effectLst/>
+        </c:spPr>
+        <c:txPr>
+          <a:bodyPr rot="-60000000" spcFirstLastPara="1" vertOverflow="ellipsis" vert="horz" wrap="square" anchor="ctr" anchorCtr="1"/>
+          <a:lstStyle/>
+          <a:p>
+            <a:pPr>
+              <a:defRPr sz="1197" b="0" i="0" u="none" strike="noStrike" kern="1200" baseline="0">
+                <a:solidFill>
+                  <a:schemeClr val="tx1">
+                    <a:lumMod val="65000"/>
+                    <a:lumOff val="35000"/>
+                  </a:schemeClr>
+                </a:solidFill>
+                <a:latin typeface="+mn-lt"/>
+                <a:ea typeface="+mn-ea"/>
+                <a:cs typeface="+mn-cs"/>
+              </a:defRPr>
+            </a:pPr>
+            <a:endParaRPr lang="en-US"/>
+          </a:p>
+        </c:txPr>
+        <c:crossAx val="486096271"/>
+        <c:crosses val="autoZero"/>
+        <c:crossBetween val="midCat"/>
+      </c:valAx>
+      <c:valAx>
+        <c:axId val="486096271"/>
+        <c:scaling>
+          <c:orientation val="minMax"/>
+        </c:scaling>
+        <c:delete val="0"/>
+        <c:axPos val="l"/>
+        <c:majorGridlines>
+          <c:spPr>
+            <a:ln w="9525" cap="flat" cmpd="sng" algn="ctr">
+              <a:solidFill>
+                <a:schemeClr val="tx1">
+                  <a:lumMod val="15000"/>
+                  <a:lumOff val="85000"/>
+                </a:schemeClr>
+              </a:solidFill>
+              <a:round/>
+            </a:ln>
+            <a:effectLst/>
+          </c:spPr>
+        </c:majorGridlines>
+        <c:numFmt formatCode="General" sourceLinked="1"/>
+        <c:majorTickMark val="none"/>
+        <c:minorTickMark val="none"/>
+        <c:tickLblPos val="nextTo"/>
+        <c:spPr>
+          <a:noFill/>
+          <a:ln w="9525" cap="flat" cmpd="sng" algn="ctr">
+            <a:solidFill>
+              <a:schemeClr val="tx1">
+                <a:lumMod val="25000"/>
+                <a:lumOff val="75000"/>
+              </a:schemeClr>
+            </a:solidFill>
+            <a:round/>
+          </a:ln>
+          <a:effectLst/>
+        </c:spPr>
+        <c:txPr>
+          <a:bodyPr rot="-60000000" spcFirstLastPara="1" vertOverflow="ellipsis" vert="horz" wrap="square" anchor="ctr" anchorCtr="1"/>
+          <a:lstStyle/>
+          <a:p>
+            <a:pPr>
+              <a:defRPr sz="1197" b="0" i="0" u="none" strike="noStrike" kern="1200" baseline="0">
+                <a:solidFill>
+                  <a:schemeClr val="tx1">
+                    <a:lumMod val="65000"/>
+                    <a:lumOff val="35000"/>
+                  </a:schemeClr>
+                </a:solidFill>
+                <a:latin typeface="+mn-lt"/>
+                <a:ea typeface="+mn-ea"/>
+                <a:cs typeface="+mn-cs"/>
+              </a:defRPr>
+            </a:pPr>
+            <a:endParaRPr lang="en-US"/>
+          </a:p>
+        </c:txPr>
+        <c:crossAx val="689937856"/>
+        <c:crosses val="autoZero"/>
+        <c:crossBetween val="midCat"/>
+      </c:valAx>
+      <c:spPr>
+        <a:noFill/>
+        <a:ln>
+          <a:noFill/>
+        </a:ln>
+        <a:effectLst/>
+      </c:spPr>
+    </c:plotArea>
+    <c:legend>
+      <c:legendPos val="b"/>
+      <c:overlay val="0"/>
+      <c:spPr>
+        <a:noFill/>
+        <a:ln>
+          <a:noFill/>
+        </a:ln>
+        <a:effectLst/>
+      </c:spPr>
+      <c:txPr>
+        <a:bodyPr rot="0" spcFirstLastPara="1" vertOverflow="ellipsis" vert="horz" wrap="square" anchor="ctr" anchorCtr="1"/>
+        <a:lstStyle/>
+        <a:p>
+          <a:pPr>
+            <a:defRPr sz="1197" b="0" i="0" u="none" strike="noStrike" kern="1200" baseline="0">
+              <a:solidFill>
+                <a:schemeClr val="tx1">
+                  <a:lumMod val="65000"/>
+                  <a:lumOff val="35000"/>
+                </a:schemeClr>
+              </a:solidFill>
+              <a:latin typeface="+mn-lt"/>
+              <a:ea typeface="+mn-ea"/>
+              <a:cs typeface="+mn-cs"/>
+            </a:defRPr>
+          </a:pPr>
+          <a:endParaRPr lang="en-US"/>
+        </a:p>
+      </c:txPr>
+    </c:legend>
+    <c:plotVisOnly val="1"/>
+    <c:dispBlanksAs val="gap"/>
+    <c:showDLblsOverMax val="0"/>
+    <c:extLst>
+      <c:ext xmlns:c16r3="http://schemas.microsoft.com/office/drawing/2017/03/chart" uri="{56B9EC1D-385E-4148-901F-78D8002777C0}">
+        <c16r3:dataDisplayOptions16>
+          <c16r3:dispNaAsBlank val="1"/>
+        </c16r3:dataDisplayOptions16>
+      </c:ext>
+    </c:extLst>
+  </c:chart>
+  <c:spPr>
+    <a:noFill/>
+    <a:ln>
+      <a:noFill/>
+    </a:ln>
+    <a:effectLst/>
+  </c:spPr>
+  <c:txPr>
+    <a:bodyPr/>
+    <a:lstStyle/>
+    <a:p>
+      <a:pPr>
+        <a:defRPr/>
+      </a:pPr>
+      <a:endParaRPr lang="en-US"/>
+    </a:p>
+  </c:txPr>
+  <c:externalData r:id="rId3">
+    <c:autoUpdate val="0"/>
+  </c:externalData>
+</c:chartSpace>
+</file>
+
+<file path=ppt/charts/chart8.xml><?xml version="1.0" encoding="utf-8"?>
+<c:chartSpace xmlns:c="http://schemas.openxmlformats.org/drawingml/2006/chart" xmlns:a="http://schemas.openxmlformats.org/drawingml/2006/main" xmlns:r="http://schemas.openxmlformats.org/officeDocument/2006/relationships" xmlns:c16r2="http://schemas.microsoft.com/office/drawing/2015/06/chart">
+  <c:date1904 val="0"/>
+  <c:lang val="en-US"/>
+  <c:roundedCorners val="0"/>
+  <mc:AlternateContent xmlns:mc="http://schemas.openxmlformats.org/markup-compatibility/2006">
+    <mc:Choice xmlns:c14="http://schemas.microsoft.com/office/drawing/2007/8/2/chart" Requires="c14">
+      <c14:style val="102"/>
+    </mc:Choice>
+    <mc:Fallback>
+      <c:style val="2"/>
+    </mc:Fallback>
+  </mc:AlternateContent>
+  <c:chart>
+    <c:autoTitleDeleted val="0"/>
+    <c:plotArea>
+      <c:layout/>
+      <c:scatterChart>
+        <c:scatterStyle val="lineMarker"/>
+        <c:varyColors val="0"/>
+        <c:ser>
+          <c:idx val="0"/>
+          <c:order val="0"/>
+          <c:tx>
+            <c:strRef>
+              <c:f>Sheet1!$B$1</c:f>
+              <c:strCache>
+                <c:ptCount val="1"/>
+                <c:pt idx="0">
+                  <c:v>Y</c:v>
+                </c:pt>
+              </c:strCache>
+            </c:strRef>
+          </c:tx>
+          <c:spPr>
+            <a:ln w="38100" cap="rnd">
+              <a:noFill/>
+              <a:round/>
+            </a:ln>
+            <a:effectLst/>
+          </c:spPr>
+          <c:marker>
+            <c:symbol val="circle"/>
+            <c:size val="5"/>
+            <c:spPr>
+              <a:solidFill>
+                <a:schemeClr val="accent1"/>
+              </a:solidFill>
+              <a:ln w="9525">
+                <a:solidFill>
+                  <a:schemeClr val="accent1"/>
+                </a:solidFill>
+              </a:ln>
+              <a:effectLst/>
+            </c:spPr>
+          </c:marker>
+          <c:yVal>
+            <c:numRef>
+              <c:f>Sheet1!$B$2:$B$5</c:f>
+              <c:numCache>
+                <c:formatCode>General</c:formatCode>
+                <c:ptCount val="4"/>
+                <c:pt idx="0">
+                  <c:v>2.5</c:v>
+                </c:pt>
+                <c:pt idx="1">
+                  <c:v>4</c:v>
+                </c:pt>
+                <c:pt idx="2">
+                  <c:v>3.5</c:v>
+                </c:pt>
+                <c:pt idx="3">
+                  <c:v>6</c:v>
+                </c:pt>
+              </c:numCache>
+            </c:numRef>
+          </c:yVal>
+          <c:smooth val="0"/>
+          <c:extLst>
+            <c:ext xmlns:c16="http://schemas.microsoft.com/office/drawing/2014/chart" uri="{C3380CC4-5D6E-409C-BE32-E72D297353CC}">
+              <c16:uniqueId val="{00000000-B7DC-4BF8-8B6D-5E5E0502E957}"/>
+            </c:ext>
+          </c:extLst>
+        </c:ser>
+        <c:dLbls>
+          <c:showLegendKey val="0"/>
+          <c:showVal val="0"/>
+          <c:showCatName val="0"/>
+          <c:showSerName val="0"/>
+          <c:showPercent val="0"/>
+          <c:showBubbleSize val="0"/>
+        </c:dLbls>
+        <c:axId val="483391919"/>
+        <c:axId val="486034831"/>
+      </c:scatterChart>
+      <c:valAx>
+        <c:axId val="483391919"/>
+        <c:scaling>
+          <c:orientation val="minMax"/>
+        </c:scaling>
+        <c:delete val="0"/>
+        <c:axPos val="b"/>
+        <c:majorGridlines>
+          <c:spPr>
+            <a:ln w="9525" cap="flat" cmpd="sng" algn="ctr">
+              <a:solidFill>
+                <a:schemeClr val="tx1">
+                  <a:lumMod val="15000"/>
+                  <a:lumOff val="85000"/>
+                </a:schemeClr>
+              </a:solidFill>
+              <a:round/>
+            </a:ln>
+            <a:effectLst/>
+          </c:spPr>
+        </c:majorGridlines>
+        <c:majorTickMark val="none"/>
+        <c:minorTickMark val="none"/>
+        <c:tickLblPos val="nextTo"/>
+        <c:spPr>
+          <a:noFill/>
+          <a:ln w="9525" cap="flat" cmpd="sng" algn="ctr">
+            <a:solidFill>
+              <a:schemeClr val="tx1">
+                <a:lumMod val="25000"/>
+                <a:lumOff val="75000"/>
+              </a:schemeClr>
+            </a:solidFill>
+            <a:round/>
+          </a:ln>
+          <a:effectLst/>
+        </c:spPr>
+        <c:txPr>
+          <a:bodyPr rot="-60000000" spcFirstLastPara="1" vertOverflow="ellipsis" vert="horz" wrap="square" anchor="ctr" anchorCtr="1"/>
+          <a:lstStyle/>
+          <a:p>
+            <a:pPr>
+              <a:defRPr sz="1197" b="0" i="0" u="none" strike="noStrike" kern="1200" baseline="0">
+                <a:solidFill>
+                  <a:schemeClr val="tx1">
+                    <a:lumMod val="65000"/>
+                    <a:lumOff val="35000"/>
+                  </a:schemeClr>
+                </a:solidFill>
+                <a:latin typeface="+mn-lt"/>
+                <a:ea typeface="+mn-ea"/>
+                <a:cs typeface="+mn-cs"/>
+              </a:defRPr>
+            </a:pPr>
+            <a:endParaRPr lang="en-US"/>
+          </a:p>
+        </c:txPr>
+        <c:crossAx val="486034831"/>
+        <c:crosses val="autoZero"/>
+        <c:crossBetween val="midCat"/>
+      </c:valAx>
+      <c:valAx>
+        <c:axId val="486034831"/>
+        <c:scaling>
+          <c:orientation val="minMax"/>
+        </c:scaling>
+        <c:delete val="0"/>
+        <c:axPos val="l"/>
+        <c:majorGridlines>
+          <c:spPr>
+            <a:ln w="9525" cap="flat" cmpd="sng" algn="ctr">
+              <a:solidFill>
+                <a:schemeClr val="tx1">
+                  <a:lumMod val="15000"/>
+                  <a:lumOff val="85000"/>
+                </a:schemeClr>
+              </a:solidFill>
+              <a:round/>
+            </a:ln>
+            <a:effectLst/>
+          </c:spPr>
+        </c:majorGridlines>
+        <c:numFmt formatCode="General" sourceLinked="1"/>
+        <c:majorTickMark val="none"/>
+        <c:minorTickMark val="none"/>
+        <c:tickLblPos val="nextTo"/>
+        <c:spPr>
+          <a:noFill/>
+          <a:ln w="9525" cap="flat" cmpd="sng" algn="ctr">
+            <a:solidFill>
+              <a:schemeClr val="tx1">
+                <a:lumMod val="25000"/>
+                <a:lumOff val="75000"/>
+              </a:schemeClr>
+            </a:solidFill>
+            <a:round/>
+          </a:ln>
+          <a:effectLst/>
+        </c:spPr>
+        <c:txPr>
+          <a:bodyPr rot="-60000000" spcFirstLastPara="1" vertOverflow="ellipsis" vert="horz" wrap="square" anchor="ctr" anchorCtr="1"/>
+          <a:lstStyle/>
+          <a:p>
+            <a:pPr>
+              <a:defRPr sz="1197" b="0" i="0" u="none" strike="noStrike" kern="1200" baseline="0">
+                <a:solidFill>
+                  <a:schemeClr val="tx1">
+                    <a:lumMod val="65000"/>
+                    <a:lumOff val="35000"/>
+                  </a:schemeClr>
+                </a:solidFill>
+                <a:latin typeface="+mn-lt"/>
+                <a:ea typeface="+mn-ea"/>
+                <a:cs typeface="+mn-cs"/>
+              </a:defRPr>
+            </a:pPr>
+            <a:endParaRPr lang="en-US"/>
+          </a:p>
+        </c:txPr>
+        <c:crossAx val="483391919"/>
         <c:crosses val="autoZero"/>
         <c:crossBetween val="midCat"/>
       </c:valAx>
@@ -1839,6 +2737,126 @@
 </cs:colorStyle>
 </file>
 
+<file path=ppt/charts/colors6.xml><?xml version="1.0" encoding="utf-8"?>
+<cs:colorStyle xmlns:cs="http://schemas.microsoft.com/office/drawing/2012/chartStyle" xmlns:a="http://schemas.openxmlformats.org/drawingml/2006/main" meth="cycle" id="10">
+  <a:schemeClr val="accent1"/>
+  <a:schemeClr val="accent2"/>
+  <a:schemeClr val="accent3"/>
+  <a:schemeClr val="accent4"/>
+  <a:schemeClr val="accent5"/>
+  <a:schemeClr val="accent6"/>
+  <cs:variation/>
+  <cs:variation>
+    <a:lumMod val="60000"/>
+  </cs:variation>
+  <cs:variation>
+    <a:lumMod val="80000"/>
+    <a:lumOff val="20000"/>
+  </cs:variation>
+  <cs:variation>
+    <a:lumMod val="80000"/>
+  </cs:variation>
+  <cs:variation>
+    <a:lumMod val="60000"/>
+    <a:lumOff val="40000"/>
+  </cs:variation>
+  <cs:variation>
+    <a:lumMod val="50000"/>
+  </cs:variation>
+  <cs:variation>
+    <a:lumMod val="70000"/>
+    <a:lumOff val="30000"/>
+  </cs:variation>
+  <cs:variation>
+    <a:lumMod val="70000"/>
+  </cs:variation>
+  <cs:variation>
+    <a:lumMod val="50000"/>
+    <a:lumOff val="50000"/>
+  </cs:variation>
+</cs:colorStyle>
+</file>
+
+<file path=ppt/charts/colors7.xml><?xml version="1.0" encoding="utf-8"?>
+<cs:colorStyle xmlns:cs="http://schemas.microsoft.com/office/drawing/2012/chartStyle" xmlns:a="http://schemas.openxmlformats.org/drawingml/2006/main" meth="cycle" id="10">
+  <a:schemeClr val="accent1"/>
+  <a:schemeClr val="accent2"/>
+  <a:schemeClr val="accent3"/>
+  <a:schemeClr val="accent4"/>
+  <a:schemeClr val="accent5"/>
+  <a:schemeClr val="accent6"/>
+  <cs:variation/>
+  <cs:variation>
+    <a:lumMod val="60000"/>
+  </cs:variation>
+  <cs:variation>
+    <a:lumMod val="80000"/>
+    <a:lumOff val="20000"/>
+  </cs:variation>
+  <cs:variation>
+    <a:lumMod val="80000"/>
+  </cs:variation>
+  <cs:variation>
+    <a:lumMod val="60000"/>
+    <a:lumOff val="40000"/>
+  </cs:variation>
+  <cs:variation>
+    <a:lumMod val="50000"/>
+  </cs:variation>
+  <cs:variation>
+    <a:lumMod val="70000"/>
+    <a:lumOff val="30000"/>
+  </cs:variation>
+  <cs:variation>
+    <a:lumMod val="70000"/>
+  </cs:variation>
+  <cs:variation>
+    <a:lumMod val="50000"/>
+    <a:lumOff val="50000"/>
+  </cs:variation>
+</cs:colorStyle>
+</file>
+
+<file path=ppt/charts/colors8.xml><?xml version="1.0" encoding="utf-8"?>
+<cs:colorStyle xmlns:cs="http://schemas.microsoft.com/office/drawing/2012/chartStyle" xmlns:a="http://schemas.openxmlformats.org/drawingml/2006/main" meth="cycle" id="10">
+  <a:schemeClr val="accent1"/>
+  <a:schemeClr val="accent2"/>
+  <a:schemeClr val="accent3"/>
+  <a:schemeClr val="accent4"/>
+  <a:schemeClr val="accent5"/>
+  <a:schemeClr val="accent6"/>
+  <cs:variation/>
+  <cs:variation>
+    <a:lumMod val="60000"/>
+  </cs:variation>
+  <cs:variation>
+    <a:lumMod val="80000"/>
+    <a:lumOff val="20000"/>
+  </cs:variation>
+  <cs:variation>
+    <a:lumMod val="80000"/>
+  </cs:variation>
+  <cs:variation>
+    <a:lumMod val="60000"/>
+    <a:lumOff val="40000"/>
+  </cs:variation>
+  <cs:variation>
+    <a:lumMod val="50000"/>
+  </cs:variation>
+  <cs:variation>
+    <a:lumMod val="70000"/>
+    <a:lumOff val="30000"/>
+  </cs:variation>
+  <cs:variation>
+    <a:lumMod val="70000"/>
+  </cs:variation>
+  <cs:variation>
+    <a:lumMod val="50000"/>
+    <a:lumOff val="50000"/>
+  </cs:variation>
+</cs:colorStyle>
+</file>
+
 <file path=ppt/charts/style1.xml><?xml version="1.0" encoding="utf-8"?>
 <cs:chartStyle xmlns:cs="http://schemas.microsoft.com/office/drawing/2012/chartStyle" xmlns:a="http://schemas.openxmlformats.org/drawingml/2006/main" id="240">
   <cs:axisTitle>
@@ -3913,6 +4931,1592 @@
 </file>
 
 <file path=ppt/charts/style5.xml><?xml version="1.0" encoding="utf-8"?>
+<cs:chartStyle xmlns:cs="http://schemas.microsoft.com/office/drawing/2012/chartStyle" xmlns:a="http://schemas.openxmlformats.org/drawingml/2006/main" id="240">
+  <cs:axisTitle>
+    <cs:lnRef idx="0"/>
+    <cs:fillRef idx="0"/>
+    <cs:effectRef idx="0"/>
+    <cs:fontRef idx="minor">
+      <a:schemeClr val="tx1">
+        <a:lumMod val="65000"/>
+        <a:lumOff val="35000"/>
+      </a:schemeClr>
+    </cs:fontRef>
+    <cs:defRPr sz="1330" kern="1200"/>
+  </cs:axisTitle>
+  <cs:categoryAxis>
+    <cs:lnRef idx="0"/>
+    <cs:fillRef idx="0"/>
+    <cs:effectRef idx="0"/>
+    <cs:fontRef idx="minor">
+      <a:schemeClr val="tx1">
+        <a:lumMod val="65000"/>
+        <a:lumOff val="35000"/>
+      </a:schemeClr>
+    </cs:fontRef>
+    <cs:spPr>
+      <a:ln w="9525" cap="flat" cmpd="sng" algn="ctr">
+        <a:solidFill>
+          <a:schemeClr val="tx1">
+            <a:lumMod val="25000"/>
+            <a:lumOff val="75000"/>
+          </a:schemeClr>
+        </a:solidFill>
+        <a:round/>
+      </a:ln>
+    </cs:spPr>
+    <cs:defRPr sz="1197" kern="1200"/>
+  </cs:categoryAxis>
+  <cs:chartArea mods="allowNoFillOverride allowNoLineOverride">
+    <cs:lnRef idx="0"/>
+    <cs:fillRef idx="0"/>
+    <cs:effectRef idx="0"/>
+    <cs:fontRef idx="minor">
+      <a:schemeClr val="tx1"/>
+    </cs:fontRef>
+    <cs:spPr>
+      <a:solidFill>
+        <a:schemeClr val="bg1"/>
+      </a:solidFill>
+      <a:ln w="9525" cap="flat" cmpd="sng" algn="ctr">
+        <a:solidFill>
+          <a:schemeClr val="tx1">
+            <a:lumMod val="15000"/>
+            <a:lumOff val="85000"/>
+          </a:schemeClr>
+        </a:solidFill>
+        <a:round/>
+      </a:ln>
+    </cs:spPr>
+    <cs:defRPr sz="1330" kern="1200"/>
+  </cs:chartArea>
+  <cs:dataLabel>
+    <cs:lnRef idx="0"/>
+    <cs:fillRef idx="0"/>
+    <cs:effectRef idx="0"/>
+    <cs:fontRef idx="minor">
+      <a:schemeClr val="tx1">
+        <a:lumMod val="75000"/>
+        <a:lumOff val="25000"/>
+      </a:schemeClr>
+    </cs:fontRef>
+    <cs:defRPr sz="1197" kern="1200"/>
+  </cs:dataLabel>
+  <cs:dataLabelCallout>
+    <cs:lnRef idx="0"/>
+    <cs:fillRef idx="0"/>
+    <cs:effectRef idx="0"/>
+    <cs:fontRef idx="minor">
+      <a:schemeClr val="dk1">
+        <a:lumMod val="65000"/>
+        <a:lumOff val="35000"/>
+      </a:schemeClr>
+    </cs:fontRef>
+    <cs:spPr>
+      <a:solidFill>
+        <a:schemeClr val="lt1"/>
+      </a:solidFill>
+      <a:ln>
+        <a:solidFill>
+          <a:schemeClr val="dk1">
+            <a:lumMod val="25000"/>
+            <a:lumOff val="75000"/>
+          </a:schemeClr>
+        </a:solidFill>
+      </a:ln>
+    </cs:spPr>
+    <cs:defRPr sz="1197" kern="1200"/>
+    <cs:bodyPr rot="0" spcFirstLastPara="1" vertOverflow="clip" horzOverflow="clip" vert="horz" wrap="square" lIns="36576" tIns="18288" rIns="36576" bIns="18288" anchor="ctr" anchorCtr="1">
+      <a:spAutoFit/>
+    </cs:bodyPr>
+  </cs:dataLabelCallout>
+  <cs:dataPoint>
+    <cs:lnRef idx="0"/>
+    <cs:fillRef idx="1">
+      <cs:styleClr val="auto"/>
+    </cs:fillRef>
+    <cs:effectRef idx="0"/>
+    <cs:fontRef idx="minor">
+      <a:schemeClr val="tx1"/>
+    </cs:fontRef>
+  </cs:dataPoint>
+  <cs:dataPoint3D>
+    <cs:lnRef idx="0"/>
+    <cs:fillRef idx="1">
+      <cs:styleClr val="auto"/>
+    </cs:fillRef>
+    <cs:effectRef idx="0"/>
+    <cs:fontRef idx="minor">
+      <a:schemeClr val="tx1"/>
+    </cs:fontRef>
+  </cs:dataPoint3D>
+  <cs:dataPointLine>
+    <cs:lnRef idx="0">
+      <cs:styleClr val="auto"/>
+    </cs:lnRef>
+    <cs:fillRef idx="1"/>
+    <cs:effectRef idx="0"/>
+    <cs:fontRef idx="minor">
+      <a:schemeClr val="tx1"/>
+    </cs:fontRef>
+    <cs:spPr>
+      <a:ln w="19050" cap="rnd">
+        <a:solidFill>
+          <a:schemeClr val="phClr"/>
+        </a:solidFill>
+        <a:round/>
+      </a:ln>
+    </cs:spPr>
+  </cs:dataPointLine>
+  <cs:dataPointMarker>
+    <cs:lnRef idx="0">
+      <cs:styleClr val="auto"/>
+    </cs:lnRef>
+    <cs:fillRef idx="1">
+      <cs:styleClr val="auto"/>
+    </cs:fillRef>
+    <cs:effectRef idx="0"/>
+    <cs:fontRef idx="minor">
+      <a:schemeClr val="tx1"/>
+    </cs:fontRef>
+    <cs:spPr>
+      <a:ln w="9525">
+        <a:solidFill>
+          <a:schemeClr val="phClr"/>
+        </a:solidFill>
+      </a:ln>
+    </cs:spPr>
+  </cs:dataPointMarker>
+  <cs:dataPointMarkerLayout symbol="circle" size="5"/>
+  <cs:dataPointWireframe>
+    <cs:lnRef idx="0">
+      <cs:styleClr val="auto"/>
+    </cs:lnRef>
+    <cs:fillRef idx="0"/>
+    <cs:effectRef idx="0"/>
+    <cs:fontRef idx="minor">
+      <a:schemeClr val="dk1"/>
+    </cs:fontRef>
+    <cs:spPr>
+      <a:ln w="9525" cap="rnd">
+        <a:solidFill>
+          <a:schemeClr val="phClr"/>
+        </a:solidFill>
+        <a:round/>
+      </a:ln>
+    </cs:spPr>
+  </cs:dataPointWireframe>
+  <cs:dataTable>
+    <cs:lnRef idx="0"/>
+    <cs:fillRef idx="0"/>
+    <cs:effectRef idx="0"/>
+    <cs:fontRef idx="minor">
+      <a:schemeClr val="tx1">
+        <a:lumMod val="65000"/>
+        <a:lumOff val="35000"/>
+      </a:schemeClr>
+    </cs:fontRef>
+    <cs:spPr>
+      <a:noFill/>
+      <a:ln w="9525" cap="flat" cmpd="sng" algn="ctr">
+        <a:solidFill>
+          <a:schemeClr val="tx1">
+            <a:lumMod val="15000"/>
+            <a:lumOff val="85000"/>
+          </a:schemeClr>
+        </a:solidFill>
+        <a:round/>
+      </a:ln>
+    </cs:spPr>
+    <cs:defRPr sz="1197" kern="1200"/>
+  </cs:dataTable>
+  <cs:downBar>
+    <cs:lnRef idx="0"/>
+    <cs:fillRef idx="0"/>
+    <cs:effectRef idx="0"/>
+    <cs:fontRef idx="minor">
+      <a:schemeClr val="tx1"/>
+    </cs:fontRef>
+    <cs:spPr>
+      <a:solidFill>
+        <a:schemeClr val="dk1">
+          <a:lumMod val="75000"/>
+          <a:lumOff val="25000"/>
+        </a:schemeClr>
+      </a:solidFill>
+      <a:ln w="9525" cap="flat" cmpd="sng" algn="ctr">
+        <a:solidFill>
+          <a:schemeClr val="tx1">
+            <a:lumMod val="65000"/>
+            <a:lumOff val="35000"/>
+          </a:schemeClr>
+        </a:solidFill>
+        <a:round/>
+      </a:ln>
+    </cs:spPr>
+  </cs:downBar>
+  <cs:dropLine>
+    <cs:lnRef idx="0"/>
+    <cs:fillRef idx="0"/>
+    <cs:effectRef idx="0"/>
+    <cs:fontRef idx="minor">
+      <a:schemeClr val="tx1"/>
+    </cs:fontRef>
+    <cs:spPr>
+      <a:ln w="9525" cap="flat" cmpd="sng" algn="ctr">
+        <a:solidFill>
+          <a:schemeClr val="tx1">
+            <a:lumMod val="35000"/>
+            <a:lumOff val="65000"/>
+          </a:schemeClr>
+        </a:solidFill>
+        <a:round/>
+      </a:ln>
+    </cs:spPr>
+  </cs:dropLine>
+  <cs:errorBar>
+    <cs:lnRef idx="0"/>
+    <cs:fillRef idx="0"/>
+    <cs:effectRef idx="0"/>
+    <cs:fontRef idx="minor">
+      <a:schemeClr val="tx1"/>
+    </cs:fontRef>
+    <cs:spPr>
+      <a:ln w="9525" cap="flat" cmpd="sng" algn="ctr">
+        <a:solidFill>
+          <a:schemeClr val="tx1">
+            <a:lumMod val="65000"/>
+            <a:lumOff val="35000"/>
+          </a:schemeClr>
+        </a:solidFill>
+        <a:round/>
+      </a:ln>
+    </cs:spPr>
+  </cs:errorBar>
+  <cs:floor>
+    <cs:lnRef idx="0"/>
+    <cs:fillRef idx="0"/>
+    <cs:effectRef idx="0"/>
+    <cs:fontRef idx="minor">
+      <a:schemeClr val="tx1"/>
+    </cs:fontRef>
+    <cs:spPr>
+      <a:noFill/>
+      <a:ln>
+        <a:noFill/>
+      </a:ln>
+    </cs:spPr>
+  </cs:floor>
+  <cs:gridlineMajor>
+    <cs:lnRef idx="0"/>
+    <cs:fillRef idx="0"/>
+    <cs:effectRef idx="0"/>
+    <cs:fontRef idx="minor">
+      <a:schemeClr val="tx1"/>
+    </cs:fontRef>
+    <cs:spPr>
+      <a:ln w="9525" cap="flat" cmpd="sng" algn="ctr">
+        <a:solidFill>
+          <a:schemeClr val="tx1">
+            <a:lumMod val="15000"/>
+            <a:lumOff val="85000"/>
+          </a:schemeClr>
+        </a:solidFill>
+        <a:round/>
+      </a:ln>
+    </cs:spPr>
+  </cs:gridlineMajor>
+  <cs:gridlineMinor>
+    <cs:lnRef idx="0"/>
+    <cs:fillRef idx="0"/>
+    <cs:effectRef idx="0"/>
+    <cs:fontRef idx="minor">
+      <a:schemeClr val="tx1"/>
+    </cs:fontRef>
+    <cs:spPr>
+      <a:ln w="9525" cap="flat" cmpd="sng" algn="ctr">
+        <a:solidFill>
+          <a:schemeClr val="tx1">
+            <a:lumMod val="5000"/>
+            <a:lumOff val="95000"/>
+          </a:schemeClr>
+        </a:solidFill>
+        <a:round/>
+      </a:ln>
+    </cs:spPr>
+  </cs:gridlineMinor>
+  <cs:hiLoLine>
+    <cs:lnRef idx="0"/>
+    <cs:fillRef idx="0"/>
+    <cs:effectRef idx="0"/>
+    <cs:fontRef idx="minor">
+      <a:schemeClr val="tx1"/>
+    </cs:fontRef>
+    <cs:spPr>
+      <a:ln w="9525" cap="flat" cmpd="sng" algn="ctr">
+        <a:solidFill>
+          <a:schemeClr val="tx1">
+            <a:lumMod val="50000"/>
+            <a:lumOff val="50000"/>
+          </a:schemeClr>
+        </a:solidFill>
+        <a:round/>
+      </a:ln>
+    </cs:spPr>
+  </cs:hiLoLine>
+  <cs:leaderLine>
+    <cs:lnRef idx="0"/>
+    <cs:fillRef idx="0"/>
+    <cs:effectRef idx="0"/>
+    <cs:fontRef idx="minor">
+      <a:schemeClr val="tx1"/>
+    </cs:fontRef>
+    <cs:spPr>
+      <a:ln w="9525" cap="flat" cmpd="sng" algn="ctr">
+        <a:solidFill>
+          <a:schemeClr val="tx1">
+            <a:lumMod val="35000"/>
+            <a:lumOff val="65000"/>
+          </a:schemeClr>
+        </a:solidFill>
+        <a:round/>
+      </a:ln>
+    </cs:spPr>
+  </cs:leaderLine>
+  <cs:legend>
+    <cs:lnRef idx="0"/>
+    <cs:fillRef idx="0"/>
+    <cs:effectRef idx="0"/>
+    <cs:fontRef idx="minor">
+      <a:schemeClr val="tx1">
+        <a:lumMod val="65000"/>
+        <a:lumOff val="35000"/>
+      </a:schemeClr>
+    </cs:fontRef>
+    <cs:defRPr sz="1197" kern="1200"/>
+  </cs:legend>
+  <cs:plotArea mods="allowNoFillOverride allowNoLineOverride">
+    <cs:lnRef idx="0"/>
+    <cs:fillRef idx="0"/>
+    <cs:effectRef idx="0"/>
+    <cs:fontRef idx="minor">
+      <a:schemeClr val="tx1"/>
+    </cs:fontRef>
+  </cs:plotArea>
+  <cs:plotArea3D mods="allowNoFillOverride allowNoLineOverride">
+    <cs:lnRef idx="0"/>
+    <cs:fillRef idx="0"/>
+    <cs:effectRef idx="0"/>
+    <cs:fontRef idx="minor">
+      <a:schemeClr val="tx1"/>
+    </cs:fontRef>
+  </cs:plotArea3D>
+  <cs:seriesAxis>
+    <cs:lnRef idx="0"/>
+    <cs:fillRef idx="0"/>
+    <cs:effectRef idx="0"/>
+    <cs:fontRef idx="minor">
+      <a:schemeClr val="tx1">
+        <a:lumMod val="65000"/>
+        <a:lumOff val="35000"/>
+      </a:schemeClr>
+    </cs:fontRef>
+    <cs:defRPr sz="1197" kern="1200"/>
+  </cs:seriesAxis>
+  <cs:seriesLine>
+    <cs:lnRef idx="0"/>
+    <cs:fillRef idx="0"/>
+    <cs:effectRef idx="0"/>
+    <cs:fontRef idx="minor">
+      <a:schemeClr val="tx1"/>
+    </cs:fontRef>
+    <cs:spPr>
+      <a:ln w="9525" cap="flat" cmpd="sng" algn="ctr">
+        <a:solidFill>
+          <a:schemeClr val="tx1">
+            <a:lumMod val="35000"/>
+            <a:lumOff val="65000"/>
+          </a:schemeClr>
+        </a:solidFill>
+        <a:round/>
+      </a:ln>
+    </cs:spPr>
+  </cs:seriesLine>
+  <cs:title>
+    <cs:lnRef idx="0"/>
+    <cs:fillRef idx="0"/>
+    <cs:effectRef idx="0"/>
+    <cs:fontRef idx="minor">
+      <a:schemeClr val="tx1">
+        <a:lumMod val="65000"/>
+        <a:lumOff val="35000"/>
+      </a:schemeClr>
+    </cs:fontRef>
+    <cs:defRPr sz="1862" b="0" kern="1200" spc="0" baseline="0"/>
+  </cs:title>
+  <cs:trendline>
+    <cs:lnRef idx="0">
+      <cs:styleClr val="auto"/>
+    </cs:lnRef>
+    <cs:fillRef idx="0"/>
+    <cs:effectRef idx="0"/>
+    <cs:fontRef idx="minor">
+      <a:schemeClr val="tx1"/>
+    </cs:fontRef>
+    <cs:spPr>
+      <a:ln w="19050" cap="rnd">
+        <a:solidFill>
+          <a:schemeClr val="phClr"/>
+        </a:solidFill>
+        <a:prstDash val="sysDot"/>
+      </a:ln>
+    </cs:spPr>
+  </cs:trendline>
+  <cs:trendlineLabel>
+    <cs:lnRef idx="0"/>
+    <cs:fillRef idx="0"/>
+    <cs:effectRef idx="0"/>
+    <cs:fontRef idx="minor">
+      <a:schemeClr val="tx1">
+        <a:lumMod val="65000"/>
+        <a:lumOff val="35000"/>
+      </a:schemeClr>
+    </cs:fontRef>
+    <cs:defRPr sz="1197" kern="1200"/>
+  </cs:trendlineLabel>
+  <cs:upBar>
+    <cs:lnRef idx="0"/>
+    <cs:fillRef idx="0"/>
+    <cs:effectRef idx="0"/>
+    <cs:fontRef idx="minor">
+      <a:schemeClr val="tx1"/>
+    </cs:fontRef>
+    <cs:spPr>
+      <a:solidFill>
+        <a:schemeClr val="lt1"/>
+      </a:solidFill>
+      <a:ln w="9525" cap="flat" cmpd="sng" algn="ctr">
+        <a:solidFill>
+          <a:schemeClr val="tx1">
+            <a:lumMod val="65000"/>
+            <a:lumOff val="35000"/>
+          </a:schemeClr>
+        </a:solidFill>
+        <a:round/>
+      </a:ln>
+    </cs:spPr>
+  </cs:upBar>
+  <cs:valueAxis>
+    <cs:lnRef idx="0"/>
+    <cs:fillRef idx="0"/>
+    <cs:effectRef idx="0"/>
+    <cs:fontRef idx="minor">
+      <a:schemeClr val="tx1">
+        <a:lumMod val="65000"/>
+        <a:lumOff val="35000"/>
+      </a:schemeClr>
+    </cs:fontRef>
+    <cs:spPr>
+      <a:ln w="9525" cap="flat" cmpd="sng" algn="ctr">
+        <a:solidFill>
+          <a:schemeClr val="tx1">
+            <a:lumMod val="25000"/>
+            <a:lumOff val="75000"/>
+          </a:schemeClr>
+        </a:solidFill>
+        <a:round/>
+      </a:ln>
+    </cs:spPr>
+    <cs:defRPr sz="1197" kern="1200"/>
+  </cs:valueAxis>
+  <cs:wall>
+    <cs:lnRef idx="0"/>
+    <cs:fillRef idx="0"/>
+    <cs:effectRef idx="0"/>
+    <cs:fontRef idx="minor">
+      <a:schemeClr val="tx1"/>
+    </cs:fontRef>
+    <cs:spPr>
+      <a:noFill/>
+      <a:ln>
+        <a:noFill/>
+      </a:ln>
+    </cs:spPr>
+  </cs:wall>
+</cs:chartStyle>
+</file>
+
+<file path=ppt/charts/style6.xml><?xml version="1.0" encoding="utf-8"?>
+<cs:chartStyle xmlns:cs="http://schemas.microsoft.com/office/drawing/2012/chartStyle" xmlns:a="http://schemas.openxmlformats.org/drawingml/2006/main" id="269">
+  <cs:axisTitle>
+    <cs:lnRef idx="0"/>
+    <cs:fillRef idx="0"/>
+    <cs:effectRef idx="0"/>
+    <cs:fontRef idx="minor">
+      <a:schemeClr val="tx1">
+        <a:lumMod val="65000"/>
+        <a:lumOff val="35000"/>
+      </a:schemeClr>
+    </cs:fontRef>
+    <cs:defRPr sz="1330" kern="1200"/>
+  </cs:axisTitle>
+  <cs:categoryAxis>
+    <cs:lnRef idx="0"/>
+    <cs:fillRef idx="0"/>
+    <cs:effectRef idx="0"/>
+    <cs:fontRef idx="minor">
+      <a:schemeClr val="tx1">
+        <a:lumMod val="65000"/>
+        <a:lumOff val="35000"/>
+      </a:schemeClr>
+    </cs:fontRef>
+    <cs:spPr>
+      <a:ln w="9525" cap="flat" cmpd="sng" algn="ctr">
+        <a:solidFill>
+          <a:schemeClr val="tx1">
+            <a:lumMod val="25000"/>
+            <a:lumOff val="75000"/>
+          </a:schemeClr>
+        </a:solidFill>
+        <a:round/>
+      </a:ln>
+    </cs:spPr>
+    <cs:defRPr sz="1197" kern="1200"/>
+  </cs:categoryAxis>
+  <cs:chartArea mods="allowNoFillOverride allowNoLineOverride">
+    <cs:lnRef idx="0"/>
+    <cs:fillRef idx="0"/>
+    <cs:effectRef idx="0"/>
+    <cs:fontRef idx="minor">
+      <a:schemeClr val="tx1"/>
+    </cs:fontRef>
+    <cs:spPr>
+      <a:solidFill>
+        <a:schemeClr val="bg1"/>
+      </a:solidFill>
+      <a:ln w="9525" cap="flat" cmpd="sng" algn="ctr">
+        <a:solidFill>
+          <a:schemeClr val="tx1">
+            <a:lumMod val="15000"/>
+            <a:lumOff val="85000"/>
+          </a:schemeClr>
+        </a:solidFill>
+        <a:round/>
+      </a:ln>
+    </cs:spPr>
+    <cs:defRPr sz="1330" kern="1200"/>
+  </cs:chartArea>
+  <cs:dataLabel>
+    <cs:lnRef idx="0"/>
+    <cs:fillRef idx="0"/>
+    <cs:effectRef idx="0"/>
+    <cs:fontRef idx="minor">
+      <a:schemeClr val="tx1">
+        <a:lumMod val="75000"/>
+        <a:lumOff val="25000"/>
+      </a:schemeClr>
+    </cs:fontRef>
+    <cs:defRPr sz="1197" kern="1200"/>
+  </cs:dataLabel>
+  <cs:dataLabelCallout>
+    <cs:lnRef idx="0"/>
+    <cs:fillRef idx="0"/>
+    <cs:effectRef idx="0"/>
+    <cs:fontRef idx="minor">
+      <a:schemeClr val="dk1">
+        <a:lumMod val="65000"/>
+        <a:lumOff val="35000"/>
+      </a:schemeClr>
+    </cs:fontRef>
+    <cs:spPr>
+      <a:solidFill>
+        <a:schemeClr val="lt1"/>
+      </a:solidFill>
+      <a:ln>
+        <a:solidFill>
+          <a:schemeClr val="dk1">
+            <a:lumMod val="25000"/>
+            <a:lumOff val="75000"/>
+          </a:schemeClr>
+        </a:solidFill>
+      </a:ln>
+    </cs:spPr>
+    <cs:defRPr sz="1197" kern="1200"/>
+    <cs:bodyPr rot="0" spcFirstLastPara="1" vertOverflow="clip" horzOverflow="clip" vert="horz" wrap="square" lIns="36576" tIns="18288" rIns="36576" bIns="18288" anchor="ctr" anchorCtr="1">
+      <a:spAutoFit/>
+    </cs:bodyPr>
+  </cs:dataLabelCallout>
+  <cs:dataPoint>
+    <cs:lnRef idx="0"/>
+    <cs:fillRef idx="1">
+      <cs:styleClr val="auto"/>
+    </cs:fillRef>
+    <cs:effectRef idx="0"/>
+    <cs:fontRef idx="minor">
+      <a:schemeClr val="tx1"/>
+    </cs:fontRef>
+    <cs:spPr>
+      <a:solidFill>
+        <a:schemeClr val="phClr">
+          <a:alpha val="75000"/>
+        </a:schemeClr>
+      </a:solidFill>
+    </cs:spPr>
+  </cs:dataPoint>
+  <cs:dataPoint3D>
+    <cs:lnRef idx="0"/>
+    <cs:fillRef idx="1">
+      <cs:styleClr val="auto"/>
+    </cs:fillRef>
+    <cs:effectRef idx="0"/>
+    <cs:fontRef idx="minor">
+      <a:schemeClr val="tx1"/>
+    </cs:fontRef>
+    <cs:spPr>
+      <a:solidFill>
+        <a:schemeClr val="phClr">
+          <a:alpha val="75000"/>
+        </a:schemeClr>
+      </a:solidFill>
+    </cs:spPr>
+  </cs:dataPoint3D>
+  <cs:dataPointLine>
+    <cs:lnRef idx="0">
+      <cs:styleClr val="auto"/>
+    </cs:lnRef>
+    <cs:fillRef idx="1"/>
+    <cs:effectRef idx="0"/>
+    <cs:fontRef idx="minor">
+      <a:schemeClr val="tx1"/>
+    </cs:fontRef>
+    <cs:spPr>
+      <a:ln w="19050" cap="rnd">
+        <a:solidFill>
+          <a:schemeClr val="phClr">
+            <a:alpha val="50000"/>
+          </a:schemeClr>
+        </a:solidFill>
+        <a:round/>
+      </a:ln>
+    </cs:spPr>
+  </cs:dataPointLine>
+  <cs:dataPointMarker>
+    <cs:lnRef idx="0">
+      <cs:styleClr val="auto"/>
+    </cs:lnRef>
+    <cs:fillRef idx="1">
+      <cs:styleClr val="auto"/>
+    </cs:fillRef>
+    <cs:effectRef idx="0"/>
+    <cs:fontRef idx="minor">
+      <a:schemeClr val="tx1"/>
+    </cs:fontRef>
+    <cs:spPr>
+      <a:solidFill>
+        <a:schemeClr val="phClr"/>
+      </a:solidFill>
+      <a:ln w="9525">
+        <a:solidFill>
+          <a:schemeClr val="phClr"/>
+        </a:solidFill>
+      </a:ln>
+    </cs:spPr>
+  </cs:dataPointMarker>
+  <cs:dataPointMarkerLayout symbol="circle" size="5"/>
+  <cs:dataPointWireframe>
+    <cs:lnRef idx="0">
+      <cs:styleClr val="auto"/>
+    </cs:lnRef>
+    <cs:fillRef idx="0"/>
+    <cs:effectRef idx="0"/>
+    <cs:fontRef idx="minor">
+      <a:schemeClr val="dk1"/>
+    </cs:fontRef>
+    <cs:spPr>
+      <a:ln w="9525" cap="rnd">
+        <a:solidFill>
+          <a:schemeClr val="phClr"/>
+        </a:solidFill>
+        <a:round/>
+      </a:ln>
+    </cs:spPr>
+  </cs:dataPointWireframe>
+  <cs:dataTable>
+    <cs:lnRef idx="0"/>
+    <cs:fillRef idx="0"/>
+    <cs:effectRef idx="0"/>
+    <cs:fontRef idx="minor">
+      <a:schemeClr val="tx1">
+        <a:lumMod val="65000"/>
+        <a:lumOff val="35000"/>
+      </a:schemeClr>
+    </cs:fontRef>
+    <cs:spPr>
+      <a:noFill/>
+      <a:ln w="9525" cap="flat" cmpd="sng" algn="ctr">
+        <a:solidFill>
+          <a:schemeClr val="tx1">
+            <a:lumMod val="15000"/>
+            <a:lumOff val="85000"/>
+          </a:schemeClr>
+        </a:solidFill>
+        <a:round/>
+      </a:ln>
+    </cs:spPr>
+    <cs:defRPr sz="1197" kern="1200"/>
+  </cs:dataTable>
+  <cs:downBar>
+    <cs:lnRef idx="0"/>
+    <cs:fillRef idx="0"/>
+    <cs:effectRef idx="0"/>
+    <cs:fontRef idx="minor">
+      <a:schemeClr val="tx1"/>
+    </cs:fontRef>
+    <cs:spPr>
+      <a:solidFill>
+        <a:schemeClr val="dk1">
+          <a:lumMod val="75000"/>
+          <a:lumOff val="25000"/>
+        </a:schemeClr>
+      </a:solidFill>
+      <a:ln w="9525" cap="flat" cmpd="sng" algn="ctr">
+        <a:solidFill>
+          <a:schemeClr val="tx1">
+            <a:lumMod val="65000"/>
+            <a:lumOff val="35000"/>
+          </a:schemeClr>
+        </a:solidFill>
+        <a:round/>
+      </a:ln>
+    </cs:spPr>
+  </cs:downBar>
+  <cs:dropLine>
+    <cs:lnRef idx="0"/>
+    <cs:fillRef idx="0"/>
+    <cs:effectRef idx="0"/>
+    <cs:fontRef idx="minor">
+      <a:schemeClr val="tx1"/>
+    </cs:fontRef>
+    <cs:spPr>
+      <a:ln w="9525" cap="flat" cmpd="sng" algn="ctr">
+        <a:solidFill>
+          <a:schemeClr val="tx1">
+            <a:lumMod val="35000"/>
+            <a:lumOff val="65000"/>
+          </a:schemeClr>
+        </a:solidFill>
+        <a:round/>
+      </a:ln>
+    </cs:spPr>
+  </cs:dropLine>
+  <cs:errorBar>
+    <cs:lnRef idx="0"/>
+    <cs:fillRef idx="0"/>
+    <cs:effectRef idx="0"/>
+    <cs:fontRef idx="minor">
+      <a:schemeClr val="tx1"/>
+    </cs:fontRef>
+    <cs:spPr>
+      <a:ln w="9525" cap="flat" cmpd="sng" algn="ctr">
+        <a:solidFill>
+          <a:schemeClr val="tx1">
+            <a:lumMod val="65000"/>
+            <a:lumOff val="35000"/>
+          </a:schemeClr>
+        </a:solidFill>
+        <a:round/>
+      </a:ln>
+    </cs:spPr>
+  </cs:errorBar>
+  <cs:floor>
+    <cs:lnRef idx="0"/>
+    <cs:fillRef idx="0"/>
+    <cs:effectRef idx="0"/>
+    <cs:fontRef idx="minor">
+      <a:schemeClr val="tx1"/>
+    </cs:fontRef>
+    <cs:spPr>
+      <a:noFill/>
+      <a:ln>
+        <a:noFill/>
+      </a:ln>
+    </cs:spPr>
+  </cs:floor>
+  <cs:gridlineMajor>
+    <cs:lnRef idx="0"/>
+    <cs:fillRef idx="0"/>
+    <cs:effectRef idx="0"/>
+    <cs:fontRef idx="minor">
+      <a:schemeClr val="tx1"/>
+    </cs:fontRef>
+    <cs:spPr>
+      <a:ln w="9525" cap="flat" cmpd="sng" algn="ctr">
+        <a:solidFill>
+          <a:schemeClr val="tx1">
+            <a:lumMod val="15000"/>
+            <a:lumOff val="85000"/>
+          </a:schemeClr>
+        </a:solidFill>
+        <a:round/>
+      </a:ln>
+    </cs:spPr>
+  </cs:gridlineMajor>
+  <cs:gridlineMinor>
+    <cs:lnRef idx="0"/>
+    <cs:fillRef idx="0"/>
+    <cs:effectRef idx="0"/>
+    <cs:fontRef idx="minor">
+      <a:schemeClr val="tx1"/>
+    </cs:fontRef>
+    <cs:spPr>
+      <a:ln w="9525" cap="flat" cmpd="sng" algn="ctr">
+        <a:solidFill>
+          <a:schemeClr val="tx1">
+            <a:lumMod val="5000"/>
+            <a:lumOff val="95000"/>
+          </a:schemeClr>
+        </a:solidFill>
+        <a:round/>
+      </a:ln>
+    </cs:spPr>
+  </cs:gridlineMinor>
+  <cs:hiLoLine>
+    <cs:lnRef idx="0"/>
+    <cs:fillRef idx="0"/>
+    <cs:effectRef idx="0"/>
+    <cs:fontRef idx="minor">
+      <a:schemeClr val="tx1"/>
+    </cs:fontRef>
+    <cs:spPr>
+      <a:ln w="9525" cap="flat" cmpd="sng" algn="ctr">
+        <a:solidFill>
+          <a:schemeClr val="tx1">
+            <a:lumMod val="50000"/>
+            <a:lumOff val="50000"/>
+          </a:schemeClr>
+        </a:solidFill>
+        <a:round/>
+      </a:ln>
+    </cs:spPr>
+  </cs:hiLoLine>
+  <cs:leaderLine>
+    <cs:lnRef idx="0"/>
+    <cs:fillRef idx="0"/>
+    <cs:effectRef idx="0"/>
+    <cs:fontRef idx="minor">
+      <a:schemeClr val="tx1"/>
+    </cs:fontRef>
+    <cs:spPr>
+      <a:ln w="9525" cap="flat" cmpd="sng" algn="ctr">
+        <a:solidFill>
+          <a:schemeClr val="tx1">
+            <a:lumMod val="35000"/>
+            <a:lumOff val="65000"/>
+          </a:schemeClr>
+        </a:solidFill>
+        <a:round/>
+      </a:ln>
+    </cs:spPr>
+  </cs:leaderLine>
+  <cs:legend>
+    <cs:lnRef idx="0"/>
+    <cs:fillRef idx="0"/>
+    <cs:effectRef idx="0"/>
+    <cs:fontRef idx="minor">
+      <a:schemeClr val="tx1">
+        <a:lumMod val="65000"/>
+        <a:lumOff val="35000"/>
+      </a:schemeClr>
+    </cs:fontRef>
+    <cs:defRPr sz="1197" kern="1200"/>
+  </cs:legend>
+  <cs:plotArea mods="allowNoFillOverride allowNoLineOverride">
+    <cs:lnRef idx="0"/>
+    <cs:fillRef idx="0"/>
+    <cs:effectRef idx="0"/>
+    <cs:fontRef idx="minor">
+      <a:schemeClr val="tx1"/>
+    </cs:fontRef>
+  </cs:plotArea>
+  <cs:plotArea3D mods="allowNoFillOverride allowNoLineOverride">
+    <cs:lnRef idx="0"/>
+    <cs:fillRef idx="0"/>
+    <cs:effectRef idx="0"/>
+    <cs:fontRef idx="minor">
+      <a:schemeClr val="tx1"/>
+    </cs:fontRef>
+  </cs:plotArea3D>
+  <cs:seriesAxis>
+    <cs:lnRef idx="0"/>
+    <cs:fillRef idx="0"/>
+    <cs:effectRef idx="0"/>
+    <cs:fontRef idx="minor">
+      <a:schemeClr val="tx1">
+        <a:lumMod val="65000"/>
+        <a:lumOff val="35000"/>
+      </a:schemeClr>
+    </cs:fontRef>
+    <cs:defRPr sz="1197" kern="1200"/>
+  </cs:seriesAxis>
+  <cs:seriesLine>
+    <cs:lnRef idx="0"/>
+    <cs:fillRef idx="0"/>
+    <cs:effectRef idx="0"/>
+    <cs:fontRef idx="minor">
+      <a:schemeClr val="tx1"/>
+    </cs:fontRef>
+    <cs:spPr>
+      <a:ln w="9525" cap="flat" cmpd="sng" algn="ctr">
+        <a:solidFill>
+          <a:schemeClr val="tx1">
+            <a:lumMod val="35000"/>
+            <a:lumOff val="65000"/>
+          </a:schemeClr>
+        </a:solidFill>
+        <a:round/>
+      </a:ln>
+    </cs:spPr>
+  </cs:seriesLine>
+  <cs:title>
+    <cs:lnRef idx="0"/>
+    <cs:fillRef idx="0"/>
+    <cs:effectRef idx="0"/>
+    <cs:fontRef idx="minor">
+      <a:schemeClr val="tx1">
+        <a:lumMod val="65000"/>
+        <a:lumOff val="35000"/>
+      </a:schemeClr>
+    </cs:fontRef>
+    <cs:defRPr sz="1862" b="0" kern="1200" spc="0" baseline="0"/>
+  </cs:title>
+  <cs:trendline>
+    <cs:lnRef idx="0">
+      <cs:styleClr val="auto"/>
+    </cs:lnRef>
+    <cs:fillRef idx="0"/>
+    <cs:effectRef idx="0"/>
+    <cs:fontRef idx="minor">
+      <a:schemeClr val="tx1"/>
+    </cs:fontRef>
+    <cs:spPr>
+      <a:ln w="19050" cap="rnd">
+        <a:solidFill>
+          <a:schemeClr val="phClr"/>
+        </a:solidFill>
+        <a:prstDash val="sysDot"/>
+      </a:ln>
+    </cs:spPr>
+  </cs:trendline>
+  <cs:trendlineLabel>
+    <cs:lnRef idx="0"/>
+    <cs:fillRef idx="0"/>
+    <cs:effectRef idx="0"/>
+    <cs:fontRef idx="minor">
+      <a:schemeClr val="tx1">
+        <a:lumMod val="65000"/>
+        <a:lumOff val="35000"/>
+      </a:schemeClr>
+    </cs:fontRef>
+    <cs:defRPr sz="1197" kern="1200"/>
+  </cs:trendlineLabel>
+  <cs:upBar>
+    <cs:lnRef idx="0"/>
+    <cs:fillRef idx="0"/>
+    <cs:effectRef idx="0"/>
+    <cs:fontRef idx="minor">
+      <a:schemeClr val="tx1"/>
+    </cs:fontRef>
+    <cs:spPr>
+      <a:solidFill>
+        <a:schemeClr val="lt1"/>
+      </a:solidFill>
+      <a:ln w="9525" cap="flat" cmpd="sng" algn="ctr">
+        <a:solidFill>
+          <a:schemeClr val="tx1">
+            <a:lumMod val="65000"/>
+            <a:lumOff val="35000"/>
+          </a:schemeClr>
+        </a:solidFill>
+        <a:round/>
+      </a:ln>
+    </cs:spPr>
+  </cs:upBar>
+  <cs:valueAxis>
+    <cs:lnRef idx="0"/>
+    <cs:fillRef idx="0"/>
+    <cs:effectRef idx="0"/>
+    <cs:fontRef idx="minor">
+      <a:schemeClr val="tx1">
+        <a:lumMod val="65000"/>
+        <a:lumOff val="35000"/>
+      </a:schemeClr>
+    </cs:fontRef>
+    <cs:spPr>
+      <a:ln w="9525" cap="flat" cmpd="sng" algn="ctr">
+        <a:solidFill>
+          <a:schemeClr val="tx1">
+            <a:lumMod val="25000"/>
+            <a:lumOff val="75000"/>
+          </a:schemeClr>
+        </a:solidFill>
+        <a:round/>
+      </a:ln>
+    </cs:spPr>
+    <cs:defRPr sz="1197" kern="1200"/>
+  </cs:valueAxis>
+  <cs:wall>
+    <cs:lnRef idx="0"/>
+    <cs:fillRef idx="0"/>
+    <cs:effectRef idx="0"/>
+    <cs:fontRef idx="minor">
+      <a:schemeClr val="tx1"/>
+    </cs:fontRef>
+    <cs:spPr>
+      <a:noFill/>
+      <a:ln>
+        <a:noFill/>
+      </a:ln>
+    </cs:spPr>
+  </cs:wall>
+</cs:chartStyle>
+</file>
+
+<file path=ppt/charts/style7.xml><?xml version="1.0" encoding="utf-8"?>
+<cs:chartStyle xmlns:cs="http://schemas.microsoft.com/office/drawing/2012/chartStyle" xmlns:a="http://schemas.openxmlformats.org/drawingml/2006/main" id="269">
+  <cs:axisTitle>
+    <cs:lnRef idx="0"/>
+    <cs:fillRef idx="0"/>
+    <cs:effectRef idx="0"/>
+    <cs:fontRef idx="minor">
+      <a:schemeClr val="tx1">
+        <a:lumMod val="65000"/>
+        <a:lumOff val="35000"/>
+      </a:schemeClr>
+    </cs:fontRef>
+    <cs:defRPr sz="1330" kern="1200"/>
+  </cs:axisTitle>
+  <cs:categoryAxis>
+    <cs:lnRef idx="0"/>
+    <cs:fillRef idx="0"/>
+    <cs:effectRef idx="0"/>
+    <cs:fontRef idx="minor">
+      <a:schemeClr val="tx1">
+        <a:lumMod val="65000"/>
+        <a:lumOff val="35000"/>
+      </a:schemeClr>
+    </cs:fontRef>
+    <cs:spPr>
+      <a:ln w="9525" cap="flat" cmpd="sng" algn="ctr">
+        <a:solidFill>
+          <a:schemeClr val="tx1">
+            <a:lumMod val="25000"/>
+            <a:lumOff val="75000"/>
+          </a:schemeClr>
+        </a:solidFill>
+        <a:round/>
+      </a:ln>
+    </cs:spPr>
+    <cs:defRPr sz="1197" kern="1200"/>
+  </cs:categoryAxis>
+  <cs:chartArea mods="allowNoFillOverride allowNoLineOverride">
+    <cs:lnRef idx="0"/>
+    <cs:fillRef idx="0"/>
+    <cs:effectRef idx="0"/>
+    <cs:fontRef idx="minor">
+      <a:schemeClr val="tx1"/>
+    </cs:fontRef>
+    <cs:spPr>
+      <a:solidFill>
+        <a:schemeClr val="bg1"/>
+      </a:solidFill>
+      <a:ln w="9525" cap="flat" cmpd="sng" algn="ctr">
+        <a:solidFill>
+          <a:schemeClr val="tx1">
+            <a:lumMod val="15000"/>
+            <a:lumOff val="85000"/>
+          </a:schemeClr>
+        </a:solidFill>
+        <a:round/>
+      </a:ln>
+    </cs:spPr>
+    <cs:defRPr sz="1330" kern="1200"/>
+  </cs:chartArea>
+  <cs:dataLabel>
+    <cs:lnRef idx="0"/>
+    <cs:fillRef idx="0"/>
+    <cs:effectRef idx="0"/>
+    <cs:fontRef idx="minor">
+      <a:schemeClr val="tx1">
+        <a:lumMod val="75000"/>
+        <a:lumOff val="25000"/>
+      </a:schemeClr>
+    </cs:fontRef>
+    <cs:defRPr sz="1197" kern="1200"/>
+  </cs:dataLabel>
+  <cs:dataLabelCallout>
+    <cs:lnRef idx="0"/>
+    <cs:fillRef idx="0"/>
+    <cs:effectRef idx="0"/>
+    <cs:fontRef idx="minor">
+      <a:schemeClr val="dk1">
+        <a:lumMod val="65000"/>
+        <a:lumOff val="35000"/>
+      </a:schemeClr>
+    </cs:fontRef>
+    <cs:spPr>
+      <a:solidFill>
+        <a:schemeClr val="lt1"/>
+      </a:solidFill>
+      <a:ln>
+        <a:solidFill>
+          <a:schemeClr val="dk1">
+            <a:lumMod val="25000"/>
+            <a:lumOff val="75000"/>
+          </a:schemeClr>
+        </a:solidFill>
+      </a:ln>
+    </cs:spPr>
+    <cs:defRPr sz="1197" kern="1200"/>
+    <cs:bodyPr rot="0" spcFirstLastPara="1" vertOverflow="clip" horzOverflow="clip" vert="horz" wrap="square" lIns="36576" tIns="18288" rIns="36576" bIns="18288" anchor="ctr" anchorCtr="1">
+      <a:spAutoFit/>
+    </cs:bodyPr>
+  </cs:dataLabelCallout>
+  <cs:dataPoint>
+    <cs:lnRef idx="0"/>
+    <cs:fillRef idx="1">
+      <cs:styleClr val="auto"/>
+    </cs:fillRef>
+    <cs:effectRef idx="0"/>
+    <cs:fontRef idx="minor">
+      <a:schemeClr val="tx1"/>
+    </cs:fontRef>
+    <cs:spPr>
+      <a:solidFill>
+        <a:schemeClr val="phClr">
+          <a:alpha val="75000"/>
+        </a:schemeClr>
+      </a:solidFill>
+    </cs:spPr>
+  </cs:dataPoint>
+  <cs:dataPoint3D>
+    <cs:lnRef idx="0"/>
+    <cs:fillRef idx="1">
+      <cs:styleClr val="auto"/>
+    </cs:fillRef>
+    <cs:effectRef idx="0"/>
+    <cs:fontRef idx="minor">
+      <a:schemeClr val="tx1"/>
+    </cs:fontRef>
+    <cs:spPr>
+      <a:solidFill>
+        <a:schemeClr val="phClr">
+          <a:alpha val="75000"/>
+        </a:schemeClr>
+      </a:solidFill>
+    </cs:spPr>
+  </cs:dataPoint3D>
+  <cs:dataPointLine>
+    <cs:lnRef idx="0">
+      <cs:styleClr val="auto"/>
+    </cs:lnRef>
+    <cs:fillRef idx="1"/>
+    <cs:effectRef idx="0"/>
+    <cs:fontRef idx="minor">
+      <a:schemeClr val="tx1"/>
+    </cs:fontRef>
+    <cs:spPr>
+      <a:ln w="19050" cap="rnd">
+        <a:solidFill>
+          <a:schemeClr val="phClr">
+            <a:alpha val="50000"/>
+          </a:schemeClr>
+        </a:solidFill>
+        <a:round/>
+      </a:ln>
+    </cs:spPr>
+  </cs:dataPointLine>
+  <cs:dataPointMarker>
+    <cs:lnRef idx="0">
+      <cs:styleClr val="auto"/>
+    </cs:lnRef>
+    <cs:fillRef idx="1">
+      <cs:styleClr val="auto"/>
+    </cs:fillRef>
+    <cs:effectRef idx="0"/>
+    <cs:fontRef idx="minor">
+      <a:schemeClr val="tx1"/>
+    </cs:fontRef>
+    <cs:spPr>
+      <a:solidFill>
+        <a:schemeClr val="phClr"/>
+      </a:solidFill>
+      <a:ln w="9525">
+        <a:solidFill>
+          <a:schemeClr val="phClr"/>
+        </a:solidFill>
+      </a:ln>
+    </cs:spPr>
+  </cs:dataPointMarker>
+  <cs:dataPointMarkerLayout symbol="circle" size="5"/>
+  <cs:dataPointWireframe>
+    <cs:lnRef idx="0">
+      <cs:styleClr val="auto"/>
+    </cs:lnRef>
+    <cs:fillRef idx="0"/>
+    <cs:effectRef idx="0"/>
+    <cs:fontRef idx="minor">
+      <a:schemeClr val="dk1"/>
+    </cs:fontRef>
+    <cs:spPr>
+      <a:ln w="9525" cap="rnd">
+        <a:solidFill>
+          <a:schemeClr val="phClr"/>
+        </a:solidFill>
+        <a:round/>
+      </a:ln>
+    </cs:spPr>
+  </cs:dataPointWireframe>
+  <cs:dataTable>
+    <cs:lnRef idx="0"/>
+    <cs:fillRef idx="0"/>
+    <cs:effectRef idx="0"/>
+    <cs:fontRef idx="minor">
+      <a:schemeClr val="tx1">
+        <a:lumMod val="65000"/>
+        <a:lumOff val="35000"/>
+      </a:schemeClr>
+    </cs:fontRef>
+    <cs:spPr>
+      <a:noFill/>
+      <a:ln w="9525" cap="flat" cmpd="sng" algn="ctr">
+        <a:solidFill>
+          <a:schemeClr val="tx1">
+            <a:lumMod val="15000"/>
+            <a:lumOff val="85000"/>
+          </a:schemeClr>
+        </a:solidFill>
+        <a:round/>
+      </a:ln>
+    </cs:spPr>
+    <cs:defRPr sz="1197" kern="1200"/>
+  </cs:dataTable>
+  <cs:downBar>
+    <cs:lnRef idx="0"/>
+    <cs:fillRef idx="0"/>
+    <cs:effectRef idx="0"/>
+    <cs:fontRef idx="minor">
+      <a:schemeClr val="tx1"/>
+    </cs:fontRef>
+    <cs:spPr>
+      <a:solidFill>
+        <a:schemeClr val="dk1">
+          <a:lumMod val="75000"/>
+          <a:lumOff val="25000"/>
+        </a:schemeClr>
+      </a:solidFill>
+      <a:ln w="9525" cap="flat" cmpd="sng" algn="ctr">
+        <a:solidFill>
+          <a:schemeClr val="tx1">
+            <a:lumMod val="65000"/>
+            <a:lumOff val="35000"/>
+          </a:schemeClr>
+        </a:solidFill>
+        <a:round/>
+      </a:ln>
+    </cs:spPr>
+  </cs:downBar>
+  <cs:dropLine>
+    <cs:lnRef idx="0"/>
+    <cs:fillRef idx="0"/>
+    <cs:effectRef idx="0"/>
+    <cs:fontRef idx="minor">
+      <a:schemeClr val="tx1"/>
+    </cs:fontRef>
+    <cs:spPr>
+      <a:ln w="9525" cap="flat" cmpd="sng" algn="ctr">
+        <a:solidFill>
+          <a:schemeClr val="tx1">
+            <a:lumMod val="35000"/>
+            <a:lumOff val="65000"/>
+          </a:schemeClr>
+        </a:solidFill>
+        <a:round/>
+      </a:ln>
+    </cs:spPr>
+  </cs:dropLine>
+  <cs:errorBar>
+    <cs:lnRef idx="0"/>
+    <cs:fillRef idx="0"/>
+    <cs:effectRef idx="0"/>
+    <cs:fontRef idx="minor">
+      <a:schemeClr val="tx1"/>
+    </cs:fontRef>
+    <cs:spPr>
+      <a:ln w="9525" cap="flat" cmpd="sng" algn="ctr">
+        <a:solidFill>
+          <a:schemeClr val="tx1">
+            <a:lumMod val="65000"/>
+            <a:lumOff val="35000"/>
+          </a:schemeClr>
+        </a:solidFill>
+        <a:round/>
+      </a:ln>
+    </cs:spPr>
+  </cs:errorBar>
+  <cs:floor>
+    <cs:lnRef idx="0"/>
+    <cs:fillRef idx="0"/>
+    <cs:effectRef idx="0"/>
+    <cs:fontRef idx="minor">
+      <a:schemeClr val="tx1"/>
+    </cs:fontRef>
+    <cs:spPr>
+      <a:noFill/>
+      <a:ln>
+        <a:noFill/>
+      </a:ln>
+    </cs:spPr>
+  </cs:floor>
+  <cs:gridlineMajor>
+    <cs:lnRef idx="0"/>
+    <cs:fillRef idx="0"/>
+    <cs:effectRef idx="0"/>
+    <cs:fontRef idx="minor">
+      <a:schemeClr val="tx1"/>
+    </cs:fontRef>
+    <cs:spPr>
+      <a:ln w="9525" cap="flat" cmpd="sng" algn="ctr">
+        <a:solidFill>
+          <a:schemeClr val="tx1">
+            <a:lumMod val="15000"/>
+            <a:lumOff val="85000"/>
+          </a:schemeClr>
+        </a:solidFill>
+        <a:round/>
+      </a:ln>
+    </cs:spPr>
+  </cs:gridlineMajor>
+  <cs:gridlineMinor>
+    <cs:lnRef idx="0"/>
+    <cs:fillRef idx="0"/>
+    <cs:effectRef idx="0"/>
+    <cs:fontRef idx="minor">
+      <a:schemeClr val="tx1"/>
+    </cs:fontRef>
+    <cs:spPr>
+      <a:ln w="9525" cap="flat" cmpd="sng" algn="ctr">
+        <a:solidFill>
+          <a:schemeClr val="tx1">
+            <a:lumMod val="5000"/>
+            <a:lumOff val="95000"/>
+          </a:schemeClr>
+        </a:solidFill>
+        <a:round/>
+      </a:ln>
+    </cs:spPr>
+  </cs:gridlineMinor>
+  <cs:hiLoLine>
+    <cs:lnRef idx="0"/>
+    <cs:fillRef idx="0"/>
+    <cs:effectRef idx="0"/>
+    <cs:fontRef idx="minor">
+      <a:schemeClr val="tx1"/>
+    </cs:fontRef>
+    <cs:spPr>
+      <a:ln w="9525" cap="flat" cmpd="sng" algn="ctr">
+        <a:solidFill>
+          <a:schemeClr val="tx1">
+            <a:lumMod val="50000"/>
+            <a:lumOff val="50000"/>
+          </a:schemeClr>
+        </a:solidFill>
+        <a:round/>
+      </a:ln>
+    </cs:spPr>
+  </cs:hiLoLine>
+  <cs:leaderLine>
+    <cs:lnRef idx="0"/>
+    <cs:fillRef idx="0"/>
+    <cs:effectRef idx="0"/>
+    <cs:fontRef idx="minor">
+      <a:schemeClr val="tx1"/>
+    </cs:fontRef>
+    <cs:spPr>
+      <a:ln w="9525" cap="flat" cmpd="sng" algn="ctr">
+        <a:solidFill>
+          <a:schemeClr val="tx1">
+            <a:lumMod val="35000"/>
+            <a:lumOff val="65000"/>
+          </a:schemeClr>
+        </a:solidFill>
+        <a:round/>
+      </a:ln>
+    </cs:spPr>
+  </cs:leaderLine>
+  <cs:legend>
+    <cs:lnRef idx="0"/>
+    <cs:fillRef idx="0"/>
+    <cs:effectRef idx="0"/>
+    <cs:fontRef idx="minor">
+      <a:schemeClr val="tx1">
+        <a:lumMod val="65000"/>
+        <a:lumOff val="35000"/>
+      </a:schemeClr>
+    </cs:fontRef>
+    <cs:defRPr sz="1197" kern="1200"/>
+  </cs:legend>
+  <cs:plotArea mods="allowNoFillOverride allowNoLineOverride">
+    <cs:lnRef idx="0"/>
+    <cs:fillRef idx="0"/>
+    <cs:effectRef idx="0"/>
+    <cs:fontRef idx="minor">
+      <a:schemeClr val="tx1"/>
+    </cs:fontRef>
+  </cs:plotArea>
+  <cs:plotArea3D mods="allowNoFillOverride allowNoLineOverride">
+    <cs:lnRef idx="0"/>
+    <cs:fillRef idx="0"/>
+    <cs:effectRef idx="0"/>
+    <cs:fontRef idx="minor">
+      <a:schemeClr val="tx1"/>
+    </cs:fontRef>
+  </cs:plotArea3D>
+  <cs:seriesAxis>
+    <cs:lnRef idx="0"/>
+    <cs:fillRef idx="0"/>
+    <cs:effectRef idx="0"/>
+    <cs:fontRef idx="minor">
+      <a:schemeClr val="tx1">
+        <a:lumMod val="65000"/>
+        <a:lumOff val="35000"/>
+      </a:schemeClr>
+    </cs:fontRef>
+    <cs:defRPr sz="1197" kern="1200"/>
+  </cs:seriesAxis>
+  <cs:seriesLine>
+    <cs:lnRef idx="0"/>
+    <cs:fillRef idx="0"/>
+    <cs:effectRef idx="0"/>
+    <cs:fontRef idx="minor">
+      <a:schemeClr val="tx1"/>
+    </cs:fontRef>
+    <cs:spPr>
+      <a:ln w="9525" cap="flat" cmpd="sng" algn="ctr">
+        <a:solidFill>
+          <a:schemeClr val="tx1">
+            <a:lumMod val="35000"/>
+            <a:lumOff val="65000"/>
+          </a:schemeClr>
+        </a:solidFill>
+        <a:round/>
+      </a:ln>
+    </cs:spPr>
+  </cs:seriesLine>
+  <cs:title>
+    <cs:lnRef idx="0"/>
+    <cs:fillRef idx="0"/>
+    <cs:effectRef idx="0"/>
+    <cs:fontRef idx="minor">
+      <a:schemeClr val="tx1">
+        <a:lumMod val="65000"/>
+        <a:lumOff val="35000"/>
+      </a:schemeClr>
+    </cs:fontRef>
+    <cs:defRPr sz="1862" b="0" kern="1200" spc="0" baseline="0"/>
+  </cs:title>
+  <cs:trendline>
+    <cs:lnRef idx="0">
+      <cs:styleClr val="auto"/>
+    </cs:lnRef>
+    <cs:fillRef idx="0"/>
+    <cs:effectRef idx="0"/>
+    <cs:fontRef idx="minor">
+      <a:schemeClr val="tx1"/>
+    </cs:fontRef>
+    <cs:spPr>
+      <a:ln w="19050" cap="rnd">
+        <a:solidFill>
+          <a:schemeClr val="phClr"/>
+        </a:solidFill>
+        <a:prstDash val="sysDot"/>
+      </a:ln>
+    </cs:spPr>
+  </cs:trendline>
+  <cs:trendlineLabel>
+    <cs:lnRef idx="0"/>
+    <cs:fillRef idx="0"/>
+    <cs:effectRef idx="0"/>
+    <cs:fontRef idx="minor">
+      <a:schemeClr val="tx1">
+        <a:lumMod val="65000"/>
+        <a:lumOff val="35000"/>
+      </a:schemeClr>
+    </cs:fontRef>
+    <cs:defRPr sz="1197" kern="1200"/>
+  </cs:trendlineLabel>
+  <cs:upBar>
+    <cs:lnRef idx="0"/>
+    <cs:fillRef idx="0"/>
+    <cs:effectRef idx="0"/>
+    <cs:fontRef idx="minor">
+      <a:schemeClr val="tx1"/>
+    </cs:fontRef>
+    <cs:spPr>
+      <a:solidFill>
+        <a:schemeClr val="lt1"/>
+      </a:solidFill>
+      <a:ln w="9525" cap="flat" cmpd="sng" algn="ctr">
+        <a:solidFill>
+          <a:schemeClr val="tx1">
+            <a:lumMod val="65000"/>
+            <a:lumOff val="35000"/>
+          </a:schemeClr>
+        </a:solidFill>
+        <a:round/>
+      </a:ln>
+    </cs:spPr>
+  </cs:upBar>
+  <cs:valueAxis>
+    <cs:lnRef idx="0"/>
+    <cs:fillRef idx="0"/>
+    <cs:effectRef idx="0"/>
+    <cs:fontRef idx="minor">
+      <a:schemeClr val="tx1">
+        <a:lumMod val="65000"/>
+        <a:lumOff val="35000"/>
+      </a:schemeClr>
+    </cs:fontRef>
+    <cs:spPr>
+      <a:ln w="9525" cap="flat" cmpd="sng" algn="ctr">
+        <a:solidFill>
+          <a:schemeClr val="tx1">
+            <a:lumMod val="25000"/>
+            <a:lumOff val="75000"/>
+          </a:schemeClr>
+        </a:solidFill>
+        <a:round/>
+      </a:ln>
+    </cs:spPr>
+    <cs:defRPr sz="1197" kern="1200"/>
+  </cs:valueAxis>
+  <cs:wall>
+    <cs:lnRef idx="0"/>
+    <cs:fillRef idx="0"/>
+    <cs:effectRef idx="0"/>
+    <cs:fontRef idx="minor">
+      <a:schemeClr val="tx1"/>
+    </cs:fontRef>
+    <cs:spPr>
+      <a:noFill/>
+      <a:ln>
+        <a:noFill/>
+      </a:ln>
+    </cs:spPr>
+  </cs:wall>
+</cs:chartStyle>
+</file>
+
+<file path=ppt/charts/style8.xml><?xml version="1.0" encoding="utf-8"?>
 <cs:chartStyle xmlns:cs="http://schemas.microsoft.com/office/drawing/2012/chartStyle" xmlns:a="http://schemas.openxmlformats.org/drawingml/2006/main" id="240">
   <cs:axisTitle>
     <cs:lnRef idx="0"/>
@@ -4450,7 +7054,7 @@
           <p:cNvPr id="2" name="Title 1">
             <a:extLst>
               <a:ext uri="{FF2B5EF4-FFF2-40B4-BE49-F238E27FC236}">
-                <a16:creationId xmlns:a16="http://schemas.microsoft.com/office/drawing/2014/main" id="{245DB63E-7B80-18DE-6BB5-C57FA07C627D}"/>
+                <a16:creationId xmlns:a16="http://schemas.microsoft.com/office/drawing/2014/main" id="{2E73CFCE-06D1-AE01-A194-573D7DC0F20F}"/>
               </a:ext>
             </a:extLst>
           </p:cNvPr>
@@ -4487,7 +7091,7 @@
           <p:cNvPr id="3" name="Subtitle 2">
             <a:extLst>
               <a:ext uri="{FF2B5EF4-FFF2-40B4-BE49-F238E27FC236}">
-                <a16:creationId xmlns:a16="http://schemas.microsoft.com/office/drawing/2014/main" id="{6E2CDDA8-CFAD-B6FA-35CA-D65BB2F8B360}"/>
+                <a16:creationId xmlns:a16="http://schemas.microsoft.com/office/drawing/2014/main" id="{CECC4BC4-8161-6DE7-B967-07AEB47AA708}"/>
               </a:ext>
             </a:extLst>
           </p:cNvPr>
@@ -4557,7 +7161,7 @@
           <p:cNvPr id="4" name="Date Placeholder 3">
             <a:extLst>
               <a:ext uri="{FF2B5EF4-FFF2-40B4-BE49-F238E27FC236}">
-                <a16:creationId xmlns:a16="http://schemas.microsoft.com/office/drawing/2014/main" id="{8D7EF186-94A0-717D-2BCA-D2C9A245E2E9}"/>
+                <a16:creationId xmlns:a16="http://schemas.microsoft.com/office/drawing/2014/main" id="{11E859BC-FD2A-3ABF-02AE-D76EB006283E}"/>
               </a:ext>
             </a:extLst>
           </p:cNvPr>
@@ -4573,7 +7177,7 @@
           <a:bodyPr/>
           <a:lstStyle/>
           <a:p>
-            <a:fld id="{3A563D40-2285-42A3-A71B-7B19C275F845}" type="datetimeFigureOut">
+            <a:fld id="{E714DC4B-6458-479D-9144-1FEDB712AACC}" type="datetimeFigureOut">
               <a:rPr lang="en-US" smtClean="0"/>
               <a:t>9/13/2026</a:t>
             </a:fld>
@@ -4586,7 +7190,7 @@
           <p:cNvPr id="5" name="Footer Placeholder 4">
             <a:extLst>
               <a:ext uri="{FF2B5EF4-FFF2-40B4-BE49-F238E27FC236}">
-                <a16:creationId xmlns:a16="http://schemas.microsoft.com/office/drawing/2014/main" id="{3A0ACDD5-8213-B114-9FD0-0BAC15B953C1}"/>
+                <a16:creationId xmlns:a16="http://schemas.microsoft.com/office/drawing/2014/main" id="{DA32DCBA-3891-CAE6-7AC8-CE4A3E8AF920}"/>
               </a:ext>
             </a:extLst>
           </p:cNvPr>
@@ -4611,7 +7215,7 @@
           <p:cNvPr id="6" name="Slide Number Placeholder 5">
             <a:extLst>
               <a:ext uri="{FF2B5EF4-FFF2-40B4-BE49-F238E27FC236}">
-                <a16:creationId xmlns:a16="http://schemas.microsoft.com/office/drawing/2014/main" id="{7A755A4E-4711-EE83-4154-FF2095A8090D}"/>
+                <a16:creationId xmlns:a16="http://schemas.microsoft.com/office/drawing/2014/main" id="{9F1D7C74-69D7-2857-F03E-B1E9903C9231}"/>
               </a:ext>
             </a:extLst>
           </p:cNvPr>
@@ -4627,7 +7231,7 @@
           <a:bodyPr/>
           <a:lstStyle/>
           <a:p>
-            <a:fld id="{32B5C656-75F8-4A5E-8C6A-9C7AA7B5C5A4}" type="slidenum">
+            <a:fld id="{A60F9349-6CD5-4A62-B0BD-EE2AAB3C61D5}" type="slidenum">
               <a:rPr lang="en-US" smtClean="0"/>
               <a:t>‹#›</a:t>
             </a:fld>
@@ -4638,7 +7242,7 @@
     </p:spTree>
     <p:extLst>
       <p:ext uri="{BB962C8B-B14F-4D97-AF65-F5344CB8AC3E}">
-        <p14:creationId xmlns:p14="http://schemas.microsoft.com/office/powerpoint/2010/main" val="460314751"/>
+        <p14:creationId xmlns:p14="http://schemas.microsoft.com/office/powerpoint/2010/main" val="3077715701"/>
       </p:ext>
     </p:extLst>
   </p:cSld>
@@ -4670,7 +7274,7 @@
           <p:cNvPr id="2" name="Title 1">
             <a:extLst>
               <a:ext uri="{FF2B5EF4-FFF2-40B4-BE49-F238E27FC236}">
-                <a16:creationId xmlns:a16="http://schemas.microsoft.com/office/drawing/2014/main" id="{8F787A3E-B899-56F0-3133-A08E682FCA2C}"/>
+                <a16:creationId xmlns:a16="http://schemas.microsoft.com/office/drawing/2014/main" id="{4296B9C8-DC2B-B526-5FAD-68938F846500}"/>
               </a:ext>
             </a:extLst>
           </p:cNvPr>
@@ -4698,7 +7302,7 @@
           <p:cNvPr id="3" name="Vertical Text Placeholder 2">
             <a:extLst>
               <a:ext uri="{FF2B5EF4-FFF2-40B4-BE49-F238E27FC236}">
-                <a16:creationId xmlns:a16="http://schemas.microsoft.com/office/drawing/2014/main" id="{1237C1E3-E341-D812-E51F-D1A67AEE3CF6}"/>
+                <a16:creationId xmlns:a16="http://schemas.microsoft.com/office/drawing/2014/main" id="{D45D094E-C8B1-6375-8DEA-4A7CF4B88D42}"/>
               </a:ext>
             </a:extLst>
           </p:cNvPr>
@@ -4755,7 +7359,7 @@
           <p:cNvPr id="4" name="Date Placeholder 3">
             <a:extLst>
               <a:ext uri="{FF2B5EF4-FFF2-40B4-BE49-F238E27FC236}">
-                <a16:creationId xmlns:a16="http://schemas.microsoft.com/office/drawing/2014/main" id="{D8C5A799-065B-2166-0948-541963AC9646}"/>
+                <a16:creationId xmlns:a16="http://schemas.microsoft.com/office/drawing/2014/main" id="{C5DA1D78-E51F-DBB4-6B68-010404AECA7E}"/>
               </a:ext>
             </a:extLst>
           </p:cNvPr>
@@ -4771,7 +7375,7 @@
           <a:bodyPr/>
           <a:lstStyle/>
           <a:p>
-            <a:fld id="{3A563D40-2285-42A3-A71B-7B19C275F845}" type="datetimeFigureOut">
+            <a:fld id="{E714DC4B-6458-479D-9144-1FEDB712AACC}" type="datetimeFigureOut">
               <a:rPr lang="en-US" smtClean="0"/>
               <a:t>9/13/2026</a:t>
             </a:fld>
@@ -4784,7 +7388,7 @@
           <p:cNvPr id="5" name="Footer Placeholder 4">
             <a:extLst>
               <a:ext uri="{FF2B5EF4-FFF2-40B4-BE49-F238E27FC236}">
-                <a16:creationId xmlns:a16="http://schemas.microsoft.com/office/drawing/2014/main" id="{764A527D-42E8-709F-7652-4D52F233B9CB}"/>
+                <a16:creationId xmlns:a16="http://schemas.microsoft.com/office/drawing/2014/main" id="{E29BA718-0B26-5E45-0D87-92480D86125C}"/>
               </a:ext>
             </a:extLst>
           </p:cNvPr>
@@ -4809,7 +7413,7 @@
           <p:cNvPr id="6" name="Slide Number Placeholder 5">
             <a:extLst>
               <a:ext uri="{FF2B5EF4-FFF2-40B4-BE49-F238E27FC236}">
-                <a16:creationId xmlns:a16="http://schemas.microsoft.com/office/drawing/2014/main" id="{A1097B2C-4BB6-F61A-44AB-7FACD4D7DEC2}"/>
+                <a16:creationId xmlns:a16="http://schemas.microsoft.com/office/drawing/2014/main" id="{B958158B-83F3-FCA2-CECC-5F55ABC740F2}"/>
               </a:ext>
             </a:extLst>
           </p:cNvPr>
@@ -4825,7 +7429,7 @@
           <a:bodyPr/>
           <a:lstStyle/>
           <a:p>
-            <a:fld id="{32B5C656-75F8-4A5E-8C6A-9C7AA7B5C5A4}" type="slidenum">
+            <a:fld id="{A60F9349-6CD5-4A62-B0BD-EE2AAB3C61D5}" type="slidenum">
               <a:rPr lang="en-US" smtClean="0"/>
               <a:t>‹#›</a:t>
             </a:fld>
@@ -4836,7 +7440,7 @@
     </p:spTree>
     <p:extLst>
       <p:ext uri="{BB962C8B-B14F-4D97-AF65-F5344CB8AC3E}">
-        <p14:creationId xmlns:p14="http://schemas.microsoft.com/office/powerpoint/2010/main" val="3205633458"/>
+        <p14:creationId xmlns:p14="http://schemas.microsoft.com/office/powerpoint/2010/main" val="701955340"/>
       </p:ext>
     </p:extLst>
   </p:cSld>
@@ -4868,7 +7472,7 @@
           <p:cNvPr id="2" name="Vertical Title 1">
             <a:extLst>
               <a:ext uri="{FF2B5EF4-FFF2-40B4-BE49-F238E27FC236}">
-                <a16:creationId xmlns:a16="http://schemas.microsoft.com/office/drawing/2014/main" id="{E326B67D-0CBD-2A6D-4C7F-DB05796F1110}"/>
+                <a16:creationId xmlns:a16="http://schemas.microsoft.com/office/drawing/2014/main" id="{1E6FAFDB-4F71-3035-01F5-6C9410A7445E}"/>
               </a:ext>
             </a:extLst>
           </p:cNvPr>
@@ -4901,7 +7505,7 @@
           <p:cNvPr id="3" name="Vertical Text Placeholder 2">
             <a:extLst>
               <a:ext uri="{FF2B5EF4-FFF2-40B4-BE49-F238E27FC236}">
-                <a16:creationId xmlns:a16="http://schemas.microsoft.com/office/drawing/2014/main" id="{74E7F4C9-5875-10E5-A224-82F15F6B64C6}"/>
+                <a16:creationId xmlns:a16="http://schemas.microsoft.com/office/drawing/2014/main" id="{0FFE047B-7312-45BB-CF29-EF1951261A18}"/>
               </a:ext>
             </a:extLst>
           </p:cNvPr>
@@ -4963,7 +7567,7 @@
           <p:cNvPr id="4" name="Date Placeholder 3">
             <a:extLst>
               <a:ext uri="{FF2B5EF4-FFF2-40B4-BE49-F238E27FC236}">
-                <a16:creationId xmlns:a16="http://schemas.microsoft.com/office/drawing/2014/main" id="{53C1E1DC-7621-6A9F-D97B-A80BCD28B4A4}"/>
+                <a16:creationId xmlns:a16="http://schemas.microsoft.com/office/drawing/2014/main" id="{A3547FBD-51B7-BC63-BC71-E5CFFCE3B6C6}"/>
               </a:ext>
             </a:extLst>
           </p:cNvPr>
@@ -4979,7 +7583,7 @@
           <a:bodyPr/>
           <a:lstStyle/>
           <a:p>
-            <a:fld id="{3A563D40-2285-42A3-A71B-7B19C275F845}" type="datetimeFigureOut">
+            <a:fld id="{E714DC4B-6458-479D-9144-1FEDB712AACC}" type="datetimeFigureOut">
               <a:rPr lang="en-US" smtClean="0"/>
               <a:t>9/13/2026</a:t>
             </a:fld>
@@ -4992,7 +7596,7 @@
           <p:cNvPr id="5" name="Footer Placeholder 4">
             <a:extLst>
               <a:ext uri="{FF2B5EF4-FFF2-40B4-BE49-F238E27FC236}">
-                <a16:creationId xmlns:a16="http://schemas.microsoft.com/office/drawing/2014/main" id="{D48E5B76-5B75-3029-C417-B0A13AAF42D2}"/>
+                <a16:creationId xmlns:a16="http://schemas.microsoft.com/office/drawing/2014/main" id="{01AD2484-E63B-599A-9085-C784294F21EA}"/>
               </a:ext>
             </a:extLst>
           </p:cNvPr>
@@ -5017,7 +7621,7 @@
           <p:cNvPr id="6" name="Slide Number Placeholder 5">
             <a:extLst>
               <a:ext uri="{FF2B5EF4-FFF2-40B4-BE49-F238E27FC236}">
-                <a16:creationId xmlns:a16="http://schemas.microsoft.com/office/drawing/2014/main" id="{FF913441-F6A7-490E-D847-62EC6861395E}"/>
+                <a16:creationId xmlns:a16="http://schemas.microsoft.com/office/drawing/2014/main" id="{B1FBE9C4-50E3-52F8-F727-991B088255C6}"/>
               </a:ext>
             </a:extLst>
           </p:cNvPr>
@@ -5033,7 +7637,7 @@
           <a:bodyPr/>
           <a:lstStyle/>
           <a:p>
-            <a:fld id="{32B5C656-75F8-4A5E-8C6A-9C7AA7B5C5A4}" type="slidenum">
+            <a:fld id="{A60F9349-6CD5-4A62-B0BD-EE2AAB3C61D5}" type="slidenum">
               <a:rPr lang="en-US" smtClean="0"/>
               <a:t>‹#›</a:t>
             </a:fld>
@@ -5044,7 +7648,7 @@
     </p:spTree>
     <p:extLst>
       <p:ext uri="{BB962C8B-B14F-4D97-AF65-F5344CB8AC3E}">
-        <p14:creationId xmlns:p14="http://schemas.microsoft.com/office/powerpoint/2010/main" val="1282777077"/>
+        <p14:creationId xmlns:p14="http://schemas.microsoft.com/office/powerpoint/2010/main" val="1473559500"/>
       </p:ext>
     </p:extLst>
   </p:cSld>
@@ -5076,7 +7680,7 @@
           <p:cNvPr id="2" name="Title 1">
             <a:extLst>
               <a:ext uri="{FF2B5EF4-FFF2-40B4-BE49-F238E27FC236}">
-                <a16:creationId xmlns:a16="http://schemas.microsoft.com/office/drawing/2014/main" id="{1FD22332-AEEA-3E48-DCDC-2F9AB238D87F}"/>
+                <a16:creationId xmlns:a16="http://schemas.microsoft.com/office/drawing/2014/main" id="{BAA1119E-0C6C-46B8-6929-9271BE8AB7E1}"/>
               </a:ext>
             </a:extLst>
           </p:cNvPr>
@@ -5104,7 +7708,7 @@
           <p:cNvPr id="3" name="Content Placeholder 2">
             <a:extLst>
               <a:ext uri="{FF2B5EF4-FFF2-40B4-BE49-F238E27FC236}">
-                <a16:creationId xmlns:a16="http://schemas.microsoft.com/office/drawing/2014/main" id="{A6F1B39A-ABCA-81BD-7E39-DFBDA1C41434}"/>
+                <a16:creationId xmlns:a16="http://schemas.microsoft.com/office/drawing/2014/main" id="{649142B7-CA1D-C709-7B89-4CE87A740B49}"/>
               </a:ext>
             </a:extLst>
           </p:cNvPr>
@@ -5161,7 +7765,7 @@
           <p:cNvPr id="4" name="Date Placeholder 3">
             <a:extLst>
               <a:ext uri="{FF2B5EF4-FFF2-40B4-BE49-F238E27FC236}">
-                <a16:creationId xmlns:a16="http://schemas.microsoft.com/office/drawing/2014/main" id="{7C234B6C-60CD-91D3-0D3F-983FCD4EF666}"/>
+                <a16:creationId xmlns:a16="http://schemas.microsoft.com/office/drawing/2014/main" id="{2F361087-F5B9-ECFC-F281-D5736FEACF2F}"/>
               </a:ext>
             </a:extLst>
           </p:cNvPr>
@@ -5177,7 +7781,7 @@
           <a:bodyPr/>
           <a:lstStyle/>
           <a:p>
-            <a:fld id="{3A563D40-2285-42A3-A71B-7B19C275F845}" type="datetimeFigureOut">
+            <a:fld id="{E714DC4B-6458-479D-9144-1FEDB712AACC}" type="datetimeFigureOut">
               <a:rPr lang="en-US" smtClean="0"/>
               <a:t>9/13/2026</a:t>
             </a:fld>
@@ -5190,7 +7794,7 @@
           <p:cNvPr id="5" name="Footer Placeholder 4">
             <a:extLst>
               <a:ext uri="{FF2B5EF4-FFF2-40B4-BE49-F238E27FC236}">
-                <a16:creationId xmlns:a16="http://schemas.microsoft.com/office/drawing/2014/main" id="{292E5AAE-6FC8-86BD-ADBA-286D90A25648}"/>
+                <a16:creationId xmlns:a16="http://schemas.microsoft.com/office/drawing/2014/main" id="{F531DDE2-84F1-E977-E9CC-E40B4E8B769A}"/>
               </a:ext>
             </a:extLst>
           </p:cNvPr>
@@ -5215,7 +7819,7 @@
           <p:cNvPr id="6" name="Slide Number Placeholder 5">
             <a:extLst>
               <a:ext uri="{FF2B5EF4-FFF2-40B4-BE49-F238E27FC236}">
-                <a16:creationId xmlns:a16="http://schemas.microsoft.com/office/drawing/2014/main" id="{2068A4D6-DD59-F5BA-51BA-F677D8A5555B}"/>
+                <a16:creationId xmlns:a16="http://schemas.microsoft.com/office/drawing/2014/main" id="{E45AD488-62BE-1F67-66C6-C88D3CE39E6C}"/>
               </a:ext>
             </a:extLst>
           </p:cNvPr>
@@ -5231,7 +7835,7 @@
           <a:bodyPr/>
           <a:lstStyle/>
           <a:p>
-            <a:fld id="{32B5C656-75F8-4A5E-8C6A-9C7AA7B5C5A4}" type="slidenum">
+            <a:fld id="{A60F9349-6CD5-4A62-B0BD-EE2AAB3C61D5}" type="slidenum">
               <a:rPr lang="en-US" smtClean="0"/>
               <a:t>‹#›</a:t>
             </a:fld>
@@ -5242,7 +7846,7 @@
     </p:spTree>
     <p:extLst>
       <p:ext uri="{BB962C8B-B14F-4D97-AF65-F5344CB8AC3E}">
-        <p14:creationId xmlns:p14="http://schemas.microsoft.com/office/powerpoint/2010/main" val="390839112"/>
+        <p14:creationId xmlns:p14="http://schemas.microsoft.com/office/powerpoint/2010/main" val="2623363905"/>
       </p:ext>
     </p:extLst>
   </p:cSld>
@@ -5274,7 +7878,7 @@
           <p:cNvPr id="2" name="Title 1">
             <a:extLst>
               <a:ext uri="{FF2B5EF4-FFF2-40B4-BE49-F238E27FC236}">
-                <a16:creationId xmlns:a16="http://schemas.microsoft.com/office/drawing/2014/main" id="{3B0A5FFF-E790-6FEE-DEFA-30A1068C6051}"/>
+                <a16:creationId xmlns:a16="http://schemas.microsoft.com/office/drawing/2014/main" id="{BEFAB1C1-96CF-2710-8A29-6B5C2D3435DB}"/>
               </a:ext>
             </a:extLst>
           </p:cNvPr>
@@ -5311,7 +7915,7 @@
           <p:cNvPr id="3" name="Text Placeholder 2">
             <a:extLst>
               <a:ext uri="{FF2B5EF4-FFF2-40B4-BE49-F238E27FC236}">
-                <a16:creationId xmlns:a16="http://schemas.microsoft.com/office/drawing/2014/main" id="{A9D668E2-BF3E-5334-86BE-DF5B69CF843F}"/>
+                <a16:creationId xmlns:a16="http://schemas.microsoft.com/office/drawing/2014/main" id="{B5843D64-9A01-81A1-4F61-77D1C4890317}"/>
               </a:ext>
             </a:extLst>
           </p:cNvPr>
@@ -5436,7 +8040,7 @@
           <p:cNvPr id="4" name="Date Placeholder 3">
             <a:extLst>
               <a:ext uri="{FF2B5EF4-FFF2-40B4-BE49-F238E27FC236}">
-                <a16:creationId xmlns:a16="http://schemas.microsoft.com/office/drawing/2014/main" id="{6FD1E576-3200-2040-8FC7-EA907A1A8ABF}"/>
+                <a16:creationId xmlns:a16="http://schemas.microsoft.com/office/drawing/2014/main" id="{30E51660-1628-C17B-7184-477E70FC0993}"/>
               </a:ext>
             </a:extLst>
           </p:cNvPr>
@@ -5452,7 +8056,7 @@
           <a:bodyPr/>
           <a:lstStyle/>
           <a:p>
-            <a:fld id="{3A563D40-2285-42A3-A71B-7B19C275F845}" type="datetimeFigureOut">
+            <a:fld id="{E714DC4B-6458-479D-9144-1FEDB712AACC}" type="datetimeFigureOut">
               <a:rPr lang="en-US" smtClean="0"/>
               <a:t>9/13/2026</a:t>
             </a:fld>
@@ -5465,7 +8069,7 @@
           <p:cNvPr id="5" name="Footer Placeholder 4">
             <a:extLst>
               <a:ext uri="{FF2B5EF4-FFF2-40B4-BE49-F238E27FC236}">
-                <a16:creationId xmlns:a16="http://schemas.microsoft.com/office/drawing/2014/main" id="{E6EBAB8B-313A-F0A4-B0C1-61D3DD9FA275}"/>
+                <a16:creationId xmlns:a16="http://schemas.microsoft.com/office/drawing/2014/main" id="{DE9F457E-54DB-CB89-9CE1-D6FA5D82F95D}"/>
               </a:ext>
             </a:extLst>
           </p:cNvPr>
@@ -5490,7 +8094,7 @@
           <p:cNvPr id="6" name="Slide Number Placeholder 5">
             <a:extLst>
               <a:ext uri="{FF2B5EF4-FFF2-40B4-BE49-F238E27FC236}">
-                <a16:creationId xmlns:a16="http://schemas.microsoft.com/office/drawing/2014/main" id="{D0709D27-5667-418F-2B7B-A13DD1EAAE92}"/>
+                <a16:creationId xmlns:a16="http://schemas.microsoft.com/office/drawing/2014/main" id="{48FE34B7-B381-66AC-5860-DC7663857DD6}"/>
               </a:ext>
             </a:extLst>
           </p:cNvPr>
@@ -5506,7 +8110,7 @@
           <a:bodyPr/>
           <a:lstStyle/>
           <a:p>
-            <a:fld id="{32B5C656-75F8-4A5E-8C6A-9C7AA7B5C5A4}" type="slidenum">
+            <a:fld id="{A60F9349-6CD5-4A62-B0BD-EE2AAB3C61D5}" type="slidenum">
               <a:rPr lang="en-US" smtClean="0"/>
               <a:t>‹#›</a:t>
             </a:fld>
@@ -5517,7 +8121,7 @@
     </p:spTree>
     <p:extLst>
       <p:ext uri="{BB962C8B-B14F-4D97-AF65-F5344CB8AC3E}">
-        <p14:creationId xmlns:p14="http://schemas.microsoft.com/office/powerpoint/2010/main" val="3464108933"/>
+        <p14:creationId xmlns:p14="http://schemas.microsoft.com/office/powerpoint/2010/main" val="250316555"/>
       </p:ext>
     </p:extLst>
   </p:cSld>
@@ -5549,7 +8153,7 @@
           <p:cNvPr id="2" name="Title 1">
             <a:extLst>
               <a:ext uri="{FF2B5EF4-FFF2-40B4-BE49-F238E27FC236}">
-                <a16:creationId xmlns:a16="http://schemas.microsoft.com/office/drawing/2014/main" id="{1CBDFBC2-B17D-5738-D64D-FC02403459D2}"/>
+                <a16:creationId xmlns:a16="http://schemas.microsoft.com/office/drawing/2014/main" id="{825FA543-AB9E-BF4F-2C02-EBD491F2C8B1}"/>
               </a:ext>
             </a:extLst>
           </p:cNvPr>
@@ -5577,7 +8181,7 @@
           <p:cNvPr id="3" name="Content Placeholder 2">
             <a:extLst>
               <a:ext uri="{FF2B5EF4-FFF2-40B4-BE49-F238E27FC236}">
-                <a16:creationId xmlns:a16="http://schemas.microsoft.com/office/drawing/2014/main" id="{B5086753-41B4-AFAC-65EA-0D1A8C33FB84}"/>
+                <a16:creationId xmlns:a16="http://schemas.microsoft.com/office/drawing/2014/main" id="{68F60691-82D9-F4EE-FE6C-2DD14C440AE2}"/>
               </a:ext>
             </a:extLst>
           </p:cNvPr>
@@ -5639,7 +8243,7 @@
           <p:cNvPr id="4" name="Content Placeholder 3">
             <a:extLst>
               <a:ext uri="{FF2B5EF4-FFF2-40B4-BE49-F238E27FC236}">
-                <a16:creationId xmlns:a16="http://schemas.microsoft.com/office/drawing/2014/main" id="{255297FE-E97D-FD03-7F71-81DF474C3526}"/>
+                <a16:creationId xmlns:a16="http://schemas.microsoft.com/office/drawing/2014/main" id="{3A49D664-46E4-7A3F-DC01-333B5E93D5B7}"/>
               </a:ext>
             </a:extLst>
           </p:cNvPr>
@@ -5701,7 +8305,7 @@
           <p:cNvPr id="5" name="Date Placeholder 4">
             <a:extLst>
               <a:ext uri="{FF2B5EF4-FFF2-40B4-BE49-F238E27FC236}">
-                <a16:creationId xmlns:a16="http://schemas.microsoft.com/office/drawing/2014/main" id="{68DD9A85-9663-C592-6712-C6E426B04474}"/>
+                <a16:creationId xmlns:a16="http://schemas.microsoft.com/office/drawing/2014/main" id="{3F3F6E99-37CF-F379-0DA9-D42AB682E1E8}"/>
               </a:ext>
             </a:extLst>
           </p:cNvPr>
@@ -5717,7 +8321,7 @@
           <a:bodyPr/>
           <a:lstStyle/>
           <a:p>
-            <a:fld id="{3A563D40-2285-42A3-A71B-7B19C275F845}" type="datetimeFigureOut">
+            <a:fld id="{E714DC4B-6458-479D-9144-1FEDB712AACC}" type="datetimeFigureOut">
               <a:rPr lang="en-US" smtClean="0"/>
               <a:t>9/13/2026</a:t>
             </a:fld>
@@ -5730,7 +8334,7 @@
           <p:cNvPr id="6" name="Footer Placeholder 5">
             <a:extLst>
               <a:ext uri="{FF2B5EF4-FFF2-40B4-BE49-F238E27FC236}">
-                <a16:creationId xmlns:a16="http://schemas.microsoft.com/office/drawing/2014/main" id="{34D0C497-7441-EB1C-B286-4BFF08D119E6}"/>
+                <a16:creationId xmlns:a16="http://schemas.microsoft.com/office/drawing/2014/main" id="{0415B9C6-9476-C436-2BB4-D02CD2FE642E}"/>
               </a:ext>
             </a:extLst>
           </p:cNvPr>
@@ -5755,7 +8359,7 @@
           <p:cNvPr id="7" name="Slide Number Placeholder 6">
             <a:extLst>
               <a:ext uri="{FF2B5EF4-FFF2-40B4-BE49-F238E27FC236}">
-                <a16:creationId xmlns:a16="http://schemas.microsoft.com/office/drawing/2014/main" id="{01A7896B-8A10-8FD1-5AF8-6E463CD644FE}"/>
+                <a16:creationId xmlns:a16="http://schemas.microsoft.com/office/drawing/2014/main" id="{66432656-2E03-E65E-8857-DE5465FE4469}"/>
               </a:ext>
             </a:extLst>
           </p:cNvPr>
@@ -5771,7 +8375,7 @@
           <a:bodyPr/>
           <a:lstStyle/>
           <a:p>
-            <a:fld id="{32B5C656-75F8-4A5E-8C6A-9C7AA7B5C5A4}" type="slidenum">
+            <a:fld id="{A60F9349-6CD5-4A62-B0BD-EE2AAB3C61D5}" type="slidenum">
               <a:rPr lang="en-US" smtClean="0"/>
               <a:t>‹#›</a:t>
             </a:fld>
@@ -5782,7 +8386,7 @@
     </p:spTree>
     <p:extLst>
       <p:ext uri="{BB962C8B-B14F-4D97-AF65-F5344CB8AC3E}">
-        <p14:creationId xmlns:p14="http://schemas.microsoft.com/office/powerpoint/2010/main" val="3215641964"/>
+        <p14:creationId xmlns:p14="http://schemas.microsoft.com/office/powerpoint/2010/main" val="1070585129"/>
       </p:ext>
     </p:extLst>
   </p:cSld>
@@ -5814,7 +8418,7 @@
           <p:cNvPr id="2" name="Title 1">
             <a:extLst>
               <a:ext uri="{FF2B5EF4-FFF2-40B4-BE49-F238E27FC236}">
-                <a16:creationId xmlns:a16="http://schemas.microsoft.com/office/drawing/2014/main" id="{0D3AB633-9D17-37D5-5C79-78B7B2D2FF48}"/>
+                <a16:creationId xmlns:a16="http://schemas.microsoft.com/office/drawing/2014/main" id="{8A3DF232-BEC2-9408-EDFB-F61A7A8D4D7C}"/>
               </a:ext>
             </a:extLst>
           </p:cNvPr>
@@ -5847,7 +8451,7 @@
           <p:cNvPr id="3" name="Text Placeholder 2">
             <a:extLst>
               <a:ext uri="{FF2B5EF4-FFF2-40B4-BE49-F238E27FC236}">
-                <a16:creationId xmlns:a16="http://schemas.microsoft.com/office/drawing/2014/main" id="{218B003A-4D7C-9353-5EF4-EFEAF78CEF28}"/>
+                <a16:creationId xmlns:a16="http://schemas.microsoft.com/office/drawing/2014/main" id="{FF69AEA0-54E8-1B32-8733-FC0030F84DBF}"/>
               </a:ext>
             </a:extLst>
           </p:cNvPr>
@@ -5918,7 +8522,7 @@
           <p:cNvPr id="4" name="Content Placeholder 3">
             <a:extLst>
               <a:ext uri="{FF2B5EF4-FFF2-40B4-BE49-F238E27FC236}">
-                <a16:creationId xmlns:a16="http://schemas.microsoft.com/office/drawing/2014/main" id="{166D0A82-859D-A149-9001-200C4AD28102}"/>
+                <a16:creationId xmlns:a16="http://schemas.microsoft.com/office/drawing/2014/main" id="{ECE10058-C12A-95A3-AA97-6ACA0615CA18}"/>
               </a:ext>
             </a:extLst>
           </p:cNvPr>
@@ -5980,7 +8584,7 @@
           <p:cNvPr id="5" name="Text Placeholder 4">
             <a:extLst>
               <a:ext uri="{FF2B5EF4-FFF2-40B4-BE49-F238E27FC236}">
-                <a16:creationId xmlns:a16="http://schemas.microsoft.com/office/drawing/2014/main" id="{972DB35F-6434-8CE9-206C-1AADF4608551}"/>
+                <a16:creationId xmlns:a16="http://schemas.microsoft.com/office/drawing/2014/main" id="{4D0299B8-E660-930C-2129-E6DEF111CC5C}"/>
               </a:ext>
             </a:extLst>
           </p:cNvPr>
@@ -6051,7 +8655,7 @@
           <p:cNvPr id="6" name="Content Placeholder 5">
             <a:extLst>
               <a:ext uri="{FF2B5EF4-FFF2-40B4-BE49-F238E27FC236}">
-                <a16:creationId xmlns:a16="http://schemas.microsoft.com/office/drawing/2014/main" id="{5349831F-44F4-A229-E089-FADBE365A1BA}"/>
+                <a16:creationId xmlns:a16="http://schemas.microsoft.com/office/drawing/2014/main" id="{8DBE3106-A344-B992-A4AD-E4BCC841ECA2}"/>
               </a:ext>
             </a:extLst>
           </p:cNvPr>
@@ -6113,7 +8717,7 @@
           <p:cNvPr id="7" name="Date Placeholder 6">
             <a:extLst>
               <a:ext uri="{FF2B5EF4-FFF2-40B4-BE49-F238E27FC236}">
-                <a16:creationId xmlns:a16="http://schemas.microsoft.com/office/drawing/2014/main" id="{72C3A1DF-A3F3-EF91-04D3-7E995060DB7C}"/>
+                <a16:creationId xmlns:a16="http://schemas.microsoft.com/office/drawing/2014/main" id="{084AFC8F-3FAA-119A-D020-5EFC5908C111}"/>
               </a:ext>
             </a:extLst>
           </p:cNvPr>
@@ -6129,7 +8733,7 @@
           <a:bodyPr/>
           <a:lstStyle/>
           <a:p>
-            <a:fld id="{3A563D40-2285-42A3-A71B-7B19C275F845}" type="datetimeFigureOut">
+            <a:fld id="{E714DC4B-6458-479D-9144-1FEDB712AACC}" type="datetimeFigureOut">
               <a:rPr lang="en-US" smtClean="0"/>
               <a:t>9/13/2026</a:t>
             </a:fld>
@@ -6142,7 +8746,7 @@
           <p:cNvPr id="8" name="Footer Placeholder 7">
             <a:extLst>
               <a:ext uri="{FF2B5EF4-FFF2-40B4-BE49-F238E27FC236}">
-                <a16:creationId xmlns:a16="http://schemas.microsoft.com/office/drawing/2014/main" id="{07A3F4F3-95A7-B0C1-DB9A-F875DB5EE161}"/>
+                <a16:creationId xmlns:a16="http://schemas.microsoft.com/office/drawing/2014/main" id="{0137AB51-2A8C-8C34-7DC7-45C005F83E4B}"/>
               </a:ext>
             </a:extLst>
           </p:cNvPr>
@@ -6167,7 +8771,7 @@
           <p:cNvPr id="9" name="Slide Number Placeholder 8">
             <a:extLst>
               <a:ext uri="{FF2B5EF4-FFF2-40B4-BE49-F238E27FC236}">
-                <a16:creationId xmlns:a16="http://schemas.microsoft.com/office/drawing/2014/main" id="{FA5C7276-317C-8887-D119-1ED94786D0D0}"/>
+                <a16:creationId xmlns:a16="http://schemas.microsoft.com/office/drawing/2014/main" id="{670926FE-5AC5-DADB-D485-349AABE675A3}"/>
               </a:ext>
             </a:extLst>
           </p:cNvPr>
@@ -6183,7 +8787,7 @@
           <a:bodyPr/>
           <a:lstStyle/>
           <a:p>
-            <a:fld id="{32B5C656-75F8-4A5E-8C6A-9C7AA7B5C5A4}" type="slidenum">
+            <a:fld id="{A60F9349-6CD5-4A62-B0BD-EE2AAB3C61D5}" type="slidenum">
               <a:rPr lang="en-US" smtClean="0"/>
               <a:t>‹#›</a:t>
             </a:fld>
@@ -6194,7 +8798,7 @@
     </p:spTree>
     <p:extLst>
       <p:ext uri="{BB962C8B-B14F-4D97-AF65-F5344CB8AC3E}">
-        <p14:creationId xmlns:p14="http://schemas.microsoft.com/office/powerpoint/2010/main" val="2952240845"/>
+        <p14:creationId xmlns:p14="http://schemas.microsoft.com/office/powerpoint/2010/main" val="3055111556"/>
       </p:ext>
     </p:extLst>
   </p:cSld>
@@ -6226,7 +8830,7 @@
           <p:cNvPr id="2" name="Title 1">
             <a:extLst>
               <a:ext uri="{FF2B5EF4-FFF2-40B4-BE49-F238E27FC236}">
-                <a16:creationId xmlns:a16="http://schemas.microsoft.com/office/drawing/2014/main" id="{3531BD55-44F4-9712-DB15-C3FC7BEDA8E7}"/>
+                <a16:creationId xmlns:a16="http://schemas.microsoft.com/office/drawing/2014/main" id="{DA37E34A-8822-D565-3F44-3FF3D353CADA}"/>
               </a:ext>
             </a:extLst>
           </p:cNvPr>
@@ -6254,7 +8858,7 @@
           <p:cNvPr id="3" name="Date Placeholder 2">
             <a:extLst>
               <a:ext uri="{FF2B5EF4-FFF2-40B4-BE49-F238E27FC236}">
-                <a16:creationId xmlns:a16="http://schemas.microsoft.com/office/drawing/2014/main" id="{82598276-810C-D4F3-2932-D0173F390344}"/>
+                <a16:creationId xmlns:a16="http://schemas.microsoft.com/office/drawing/2014/main" id="{A424438F-EC97-CBD9-5766-EBD961F8B857}"/>
               </a:ext>
             </a:extLst>
           </p:cNvPr>
@@ -6270,7 +8874,7 @@
           <a:bodyPr/>
           <a:lstStyle/>
           <a:p>
-            <a:fld id="{3A563D40-2285-42A3-A71B-7B19C275F845}" type="datetimeFigureOut">
+            <a:fld id="{E714DC4B-6458-479D-9144-1FEDB712AACC}" type="datetimeFigureOut">
               <a:rPr lang="en-US" smtClean="0"/>
               <a:t>9/13/2026</a:t>
             </a:fld>
@@ -6283,7 +8887,7 @@
           <p:cNvPr id="4" name="Footer Placeholder 3">
             <a:extLst>
               <a:ext uri="{FF2B5EF4-FFF2-40B4-BE49-F238E27FC236}">
-                <a16:creationId xmlns:a16="http://schemas.microsoft.com/office/drawing/2014/main" id="{CF558375-9DC9-44F6-1847-4B6944D32804}"/>
+                <a16:creationId xmlns:a16="http://schemas.microsoft.com/office/drawing/2014/main" id="{7055FC28-3D51-5031-A7F1-E0EAC491565A}"/>
               </a:ext>
             </a:extLst>
           </p:cNvPr>
@@ -6308,7 +8912,7 @@
           <p:cNvPr id="5" name="Slide Number Placeholder 4">
             <a:extLst>
               <a:ext uri="{FF2B5EF4-FFF2-40B4-BE49-F238E27FC236}">
-                <a16:creationId xmlns:a16="http://schemas.microsoft.com/office/drawing/2014/main" id="{9B2B290C-41AE-C60B-7C00-98DC0BF89A43}"/>
+                <a16:creationId xmlns:a16="http://schemas.microsoft.com/office/drawing/2014/main" id="{11C23B64-6E6E-B714-87D4-59B2D9EAAB93}"/>
               </a:ext>
             </a:extLst>
           </p:cNvPr>
@@ -6324,7 +8928,7 @@
           <a:bodyPr/>
           <a:lstStyle/>
           <a:p>
-            <a:fld id="{32B5C656-75F8-4A5E-8C6A-9C7AA7B5C5A4}" type="slidenum">
+            <a:fld id="{A60F9349-6CD5-4A62-B0BD-EE2AAB3C61D5}" type="slidenum">
               <a:rPr lang="en-US" smtClean="0"/>
               <a:t>‹#›</a:t>
             </a:fld>
@@ -6335,7 +8939,7 @@
     </p:spTree>
     <p:extLst>
       <p:ext uri="{BB962C8B-B14F-4D97-AF65-F5344CB8AC3E}">
-        <p14:creationId xmlns:p14="http://schemas.microsoft.com/office/powerpoint/2010/main" val="2268563429"/>
+        <p14:creationId xmlns:p14="http://schemas.microsoft.com/office/powerpoint/2010/main" val="3586436058"/>
       </p:ext>
     </p:extLst>
   </p:cSld>
@@ -6367,7 +8971,7 @@
           <p:cNvPr id="2" name="Date Placeholder 1">
             <a:extLst>
               <a:ext uri="{FF2B5EF4-FFF2-40B4-BE49-F238E27FC236}">
-                <a16:creationId xmlns:a16="http://schemas.microsoft.com/office/drawing/2014/main" id="{1D0DEB26-DCE9-ECED-96A0-39C143C44DDD}"/>
+                <a16:creationId xmlns:a16="http://schemas.microsoft.com/office/drawing/2014/main" id="{548966E9-F4BD-120F-1B9E-FA9920F425BC}"/>
               </a:ext>
             </a:extLst>
           </p:cNvPr>
@@ -6383,7 +8987,7 @@
           <a:bodyPr/>
           <a:lstStyle/>
           <a:p>
-            <a:fld id="{3A563D40-2285-42A3-A71B-7B19C275F845}" type="datetimeFigureOut">
+            <a:fld id="{E714DC4B-6458-479D-9144-1FEDB712AACC}" type="datetimeFigureOut">
               <a:rPr lang="en-US" smtClean="0"/>
               <a:t>9/13/2026</a:t>
             </a:fld>
@@ -6396,7 +9000,7 @@
           <p:cNvPr id="3" name="Footer Placeholder 2">
             <a:extLst>
               <a:ext uri="{FF2B5EF4-FFF2-40B4-BE49-F238E27FC236}">
-                <a16:creationId xmlns:a16="http://schemas.microsoft.com/office/drawing/2014/main" id="{5159F8BE-DAF5-DB20-50C9-93620116CD36}"/>
+                <a16:creationId xmlns:a16="http://schemas.microsoft.com/office/drawing/2014/main" id="{7ADAF6D4-7B9C-9001-4B43-6D82D7988863}"/>
               </a:ext>
             </a:extLst>
           </p:cNvPr>
@@ -6421,7 +9025,7 @@
           <p:cNvPr id="4" name="Slide Number Placeholder 3">
             <a:extLst>
               <a:ext uri="{FF2B5EF4-FFF2-40B4-BE49-F238E27FC236}">
-                <a16:creationId xmlns:a16="http://schemas.microsoft.com/office/drawing/2014/main" id="{D953021F-F173-781A-E926-1D11CB708D59}"/>
+                <a16:creationId xmlns:a16="http://schemas.microsoft.com/office/drawing/2014/main" id="{6B51927E-5C75-C961-8A64-58D2D1B6D45B}"/>
               </a:ext>
             </a:extLst>
           </p:cNvPr>
@@ -6437,7 +9041,7 @@
           <a:bodyPr/>
           <a:lstStyle/>
           <a:p>
-            <a:fld id="{32B5C656-75F8-4A5E-8C6A-9C7AA7B5C5A4}" type="slidenum">
+            <a:fld id="{A60F9349-6CD5-4A62-B0BD-EE2AAB3C61D5}" type="slidenum">
               <a:rPr lang="en-US" smtClean="0"/>
               <a:t>‹#›</a:t>
             </a:fld>
@@ -6448,7 +9052,7 @@
     </p:spTree>
     <p:extLst>
       <p:ext uri="{BB962C8B-B14F-4D97-AF65-F5344CB8AC3E}">
-        <p14:creationId xmlns:p14="http://schemas.microsoft.com/office/powerpoint/2010/main" val="1215421805"/>
+        <p14:creationId xmlns:p14="http://schemas.microsoft.com/office/powerpoint/2010/main" val="3274580101"/>
       </p:ext>
     </p:extLst>
   </p:cSld>
@@ -6480,7 +9084,7 @@
           <p:cNvPr id="2" name="Title 1">
             <a:extLst>
               <a:ext uri="{FF2B5EF4-FFF2-40B4-BE49-F238E27FC236}">
-                <a16:creationId xmlns:a16="http://schemas.microsoft.com/office/drawing/2014/main" id="{47F59B99-6EFC-0010-0681-1FB4B8C13348}"/>
+                <a16:creationId xmlns:a16="http://schemas.microsoft.com/office/drawing/2014/main" id="{DDB992E6-B36B-2762-AEEA-0290181E0C5F}"/>
               </a:ext>
             </a:extLst>
           </p:cNvPr>
@@ -6517,7 +9121,7 @@
           <p:cNvPr id="3" name="Content Placeholder 2">
             <a:extLst>
               <a:ext uri="{FF2B5EF4-FFF2-40B4-BE49-F238E27FC236}">
-                <a16:creationId xmlns:a16="http://schemas.microsoft.com/office/drawing/2014/main" id="{B6A422C0-346A-AA93-B51E-45097F424F4E}"/>
+                <a16:creationId xmlns:a16="http://schemas.microsoft.com/office/drawing/2014/main" id="{0DAF53E5-3D2D-6E66-5234-BCDAF25349BD}"/>
               </a:ext>
             </a:extLst>
           </p:cNvPr>
@@ -6607,7 +9211,7 @@
           <p:cNvPr id="4" name="Text Placeholder 3">
             <a:extLst>
               <a:ext uri="{FF2B5EF4-FFF2-40B4-BE49-F238E27FC236}">
-                <a16:creationId xmlns:a16="http://schemas.microsoft.com/office/drawing/2014/main" id="{F26472D9-886C-8C57-F4C6-98C4D50EB4DE}"/>
+                <a16:creationId xmlns:a16="http://schemas.microsoft.com/office/drawing/2014/main" id="{7CD37FD8-93DC-6561-A815-38CEE2C359AE}"/>
               </a:ext>
             </a:extLst>
           </p:cNvPr>
@@ -6678,7 +9282,7 @@
           <p:cNvPr id="5" name="Date Placeholder 4">
             <a:extLst>
               <a:ext uri="{FF2B5EF4-FFF2-40B4-BE49-F238E27FC236}">
-                <a16:creationId xmlns:a16="http://schemas.microsoft.com/office/drawing/2014/main" id="{5F8CBF1F-6DE4-7B21-881A-2135136D3781}"/>
+                <a16:creationId xmlns:a16="http://schemas.microsoft.com/office/drawing/2014/main" id="{BC441308-68C3-FF49-9257-9226A35967DC}"/>
               </a:ext>
             </a:extLst>
           </p:cNvPr>
@@ -6694,7 +9298,7 @@
           <a:bodyPr/>
           <a:lstStyle/>
           <a:p>
-            <a:fld id="{3A563D40-2285-42A3-A71B-7B19C275F845}" type="datetimeFigureOut">
+            <a:fld id="{E714DC4B-6458-479D-9144-1FEDB712AACC}" type="datetimeFigureOut">
               <a:rPr lang="en-US" smtClean="0"/>
               <a:t>9/13/2026</a:t>
             </a:fld>
@@ -6707,7 +9311,7 @@
           <p:cNvPr id="6" name="Footer Placeholder 5">
             <a:extLst>
               <a:ext uri="{FF2B5EF4-FFF2-40B4-BE49-F238E27FC236}">
-                <a16:creationId xmlns:a16="http://schemas.microsoft.com/office/drawing/2014/main" id="{C49150CA-190C-A275-455E-6B67023FE301}"/>
+                <a16:creationId xmlns:a16="http://schemas.microsoft.com/office/drawing/2014/main" id="{21F912D2-B1F9-17F9-7BE0-D36BA4235FF6}"/>
               </a:ext>
             </a:extLst>
           </p:cNvPr>
@@ -6732,7 +9336,7 @@
           <p:cNvPr id="7" name="Slide Number Placeholder 6">
             <a:extLst>
               <a:ext uri="{FF2B5EF4-FFF2-40B4-BE49-F238E27FC236}">
-                <a16:creationId xmlns:a16="http://schemas.microsoft.com/office/drawing/2014/main" id="{A37D477E-509A-E0AA-6EE9-061DF071C0BF}"/>
+                <a16:creationId xmlns:a16="http://schemas.microsoft.com/office/drawing/2014/main" id="{2082E244-4859-2556-0971-244A5E148957}"/>
               </a:ext>
             </a:extLst>
           </p:cNvPr>
@@ -6748,7 +9352,7 @@
           <a:bodyPr/>
           <a:lstStyle/>
           <a:p>
-            <a:fld id="{32B5C656-75F8-4A5E-8C6A-9C7AA7B5C5A4}" type="slidenum">
+            <a:fld id="{A60F9349-6CD5-4A62-B0BD-EE2AAB3C61D5}" type="slidenum">
               <a:rPr lang="en-US" smtClean="0"/>
               <a:t>‹#›</a:t>
             </a:fld>
@@ -6759,7 +9363,7 @@
     </p:spTree>
     <p:extLst>
       <p:ext uri="{BB962C8B-B14F-4D97-AF65-F5344CB8AC3E}">
-        <p14:creationId xmlns:p14="http://schemas.microsoft.com/office/powerpoint/2010/main" val="1947282126"/>
+        <p14:creationId xmlns:p14="http://schemas.microsoft.com/office/powerpoint/2010/main" val="3182655248"/>
       </p:ext>
     </p:extLst>
   </p:cSld>
@@ -6791,7 +9395,7 @@
           <p:cNvPr id="2" name="Title 1">
             <a:extLst>
               <a:ext uri="{FF2B5EF4-FFF2-40B4-BE49-F238E27FC236}">
-                <a16:creationId xmlns:a16="http://schemas.microsoft.com/office/drawing/2014/main" id="{74BBF670-9E92-5E67-7434-C3E87AB93246}"/>
+                <a16:creationId xmlns:a16="http://schemas.microsoft.com/office/drawing/2014/main" id="{40241CEF-80C9-EB1A-6020-831C3873D7EB}"/>
               </a:ext>
             </a:extLst>
           </p:cNvPr>
@@ -6828,7 +9432,7 @@
           <p:cNvPr id="3" name="Picture Placeholder 2">
             <a:extLst>
               <a:ext uri="{FF2B5EF4-FFF2-40B4-BE49-F238E27FC236}">
-                <a16:creationId xmlns:a16="http://schemas.microsoft.com/office/drawing/2014/main" id="{3EFC3BC3-EA8F-1D42-E5F4-09B04D91CCCA}"/>
+                <a16:creationId xmlns:a16="http://schemas.microsoft.com/office/drawing/2014/main" id="{BA6C8C8F-4521-B1AE-A7E0-A3A2463470CA}"/>
               </a:ext>
             </a:extLst>
           </p:cNvPr>
@@ -6895,7 +9499,7 @@
           <p:cNvPr id="4" name="Text Placeholder 3">
             <a:extLst>
               <a:ext uri="{FF2B5EF4-FFF2-40B4-BE49-F238E27FC236}">
-                <a16:creationId xmlns:a16="http://schemas.microsoft.com/office/drawing/2014/main" id="{5F867160-FD60-A61B-6A45-CDCFE3CF384C}"/>
+                <a16:creationId xmlns:a16="http://schemas.microsoft.com/office/drawing/2014/main" id="{501A732F-0510-971E-E50A-41DFE7D4D62C}"/>
               </a:ext>
             </a:extLst>
           </p:cNvPr>
@@ -6966,7 +9570,7 @@
           <p:cNvPr id="5" name="Date Placeholder 4">
             <a:extLst>
               <a:ext uri="{FF2B5EF4-FFF2-40B4-BE49-F238E27FC236}">
-                <a16:creationId xmlns:a16="http://schemas.microsoft.com/office/drawing/2014/main" id="{3CB871C8-45BF-A13A-FB78-8E0C8C33307D}"/>
+                <a16:creationId xmlns:a16="http://schemas.microsoft.com/office/drawing/2014/main" id="{DDD999B9-BCAB-7E06-6EFF-BCD6C54FE7F3}"/>
               </a:ext>
             </a:extLst>
           </p:cNvPr>
@@ -6982,7 +9586,7 @@
           <a:bodyPr/>
           <a:lstStyle/>
           <a:p>
-            <a:fld id="{3A563D40-2285-42A3-A71B-7B19C275F845}" type="datetimeFigureOut">
+            <a:fld id="{E714DC4B-6458-479D-9144-1FEDB712AACC}" type="datetimeFigureOut">
               <a:rPr lang="en-US" smtClean="0"/>
               <a:t>9/13/2026</a:t>
             </a:fld>
@@ -6995,7 +9599,7 @@
           <p:cNvPr id="6" name="Footer Placeholder 5">
             <a:extLst>
               <a:ext uri="{FF2B5EF4-FFF2-40B4-BE49-F238E27FC236}">
-                <a16:creationId xmlns:a16="http://schemas.microsoft.com/office/drawing/2014/main" id="{E593313F-7E06-A56B-9DC7-432E245FEACA}"/>
+                <a16:creationId xmlns:a16="http://schemas.microsoft.com/office/drawing/2014/main" id="{6ADDE1AB-A218-5A09-1D39-B6FD11F5FE90}"/>
               </a:ext>
             </a:extLst>
           </p:cNvPr>
@@ -7020,7 +9624,7 @@
           <p:cNvPr id="7" name="Slide Number Placeholder 6">
             <a:extLst>
               <a:ext uri="{FF2B5EF4-FFF2-40B4-BE49-F238E27FC236}">
-                <a16:creationId xmlns:a16="http://schemas.microsoft.com/office/drawing/2014/main" id="{0C0ECAEC-876A-3EFA-E141-79C66C985E36}"/>
+                <a16:creationId xmlns:a16="http://schemas.microsoft.com/office/drawing/2014/main" id="{E015E28B-A356-E4C8-41E8-3897EED136DB}"/>
               </a:ext>
             </a:extLst>
           </p:cNvPr>
@@ -7036,7 +9640,7 @@
           <a:bodyPr/>
           <a:lstStyle/>
           <a:p>
-            <a:fld id="{32B5C656-75F8-4A5E-8C6A-9C7AA7B5C5A4}" type="slidenum">
+            <a:fld id="{A60F9349-6CD5-4A62-B0BD-EE2AAB3C61D5}" type="slidenum">
               <a:rPr lang="en-US" smtClean="0"/>
               <a:t>‹#›</a:t>
             </a:fld>
@@ -7047,7 +9651,7 @@
     </p:spTree>
     <p:extLst>
       <p:ext uri="{BB962C8B-B14F-4D97-AF65-F5344CB8AC3E}">
-        <p14:creationId xmlns:p14="http://schemas.microsoft.com/office/powerpoint/2010/main" val="1493007261"/>
+        <p14:creationId xmlns:p14="http://schemas.microsoft.com/office/powerpoint/2010/main" val="1846671027"/>
       </p:ext>
     </p:extLst>
   </p:cSld>
@@ -7084,7 +9688,7 @@
           <p:cNvPr id="2" name="Title Placeholder 1">
             <a:extLst>
               <a:ext uri="{FF2B5EF4-FFF2-40B4-BE49-F238E27FC236}">
-                <a16:creationId xmlns:a16="http://schemas.microsoft.com/office/drawing/2014/main" id="{9D56CE6F-B6F9-53A6-B183-229C8E797E24}"/>
+                <a16:creationId xmlns:a16="http://schemas.microsoft.com/office/drawing/2014/main" id="{8C245EFE-7138-6552-5BDE-1A581F336B28}"/>
               </a:ext>
             </a:extLst>
           </p:cNvPr>
@@ -7122,7 +9726,7 @@
           <p:cNvPr id="3" name="Text Placeholder 2">
             <a:extLst>
               <a:ext uri="{FF2B5EF4-FFF2-40B4-BE49-F238E27FC236}">
-                <a16:creationId xmlns:a16="http://schemas.microsoft.com/office/drawing/2014/main" id="{7EC629EA-0AE8-FA11-3EF6-C01F0A04E9A5}"/>
+                <a16:creationId xmlns:a16="http://schemas.microsoft.com/office/drawing/2014/main" id="{AB0D585C-E065-AD88-B3D9-6641223ECA49}"/>
               </a:ext>
             </a:extLst>
           </p:cNvPr>
@@ -7189,7 +9793,7 @@
           <p:cNvPr id="4" name="Date Placeholder 3">
             <a:extLst>
               <a:ext uri="{FF2B5EF4-FFF2-40B4-BE49-F238E27FC236}">
-                <a16:creationId xmlns:a16="http://schemas.microsoft.com/office/drawing/2014/main" id="{AC92CAD8-D26C-CD35-314D-B85F2646236D}"/>
+                <a16:creationId xmlns:a16="http://schemas.microsoft.com/office/drawing/2014/main" id="{E1EC6B73-24AC-570B-4CBB-148F817B4BB6}"/>
               </a:ext>
             </a:extLst>
           </p:cNvPr>
@@ -7223,7 +9827,7 @@
             </a:lvl1pPr>
           </a:lstStyle>
           <a:p>
-            <a:fld id="{3A563D40-2285-42A3-A71B-7B19C275F845}" type="datetimeFigureOut">
+            <a:fld id="{E714DC4B-6458-479D-9144-1FEDB712AACC}" type="datetimeFigureOut">
               <a:rPr lang="en-US" smtClean="0"/>
               <a:t>9/13/2026</a:t>
             </a:fld>
@@ -7236,7 +9840,7 @@
           <p:cNvPr id="5" name="Footer Placeholder 4">
             <a:extLst>
               <a:ext uri="{FF2B5EF4-FFF2-40B4-BE49-F238E27FC236}">
-                <a16:creationId xmlns:a16="http://schemas.microsoft.com/office/drawing/2014/main" id="{4F223890-DF54-77A9-6ED6-547E568AD4EE}"/>
+                <a16:creationId xmlns:a16="http://schemas.microsoft.com/office/drawing/2014/main" id="{178928A4-B013-E359-AF76-F2C7158A7B7B}"/>
               </a:ext>
             </a:extLst>
           </p:cNvPr>
@@ -7279,7 +9883,7 @@
           <p:cNvPr id="6" name="Slide Number Placeholder 5">
             <a:extLst>
               <a:ext uri="{FF2B5EF4-FFF2-40B4-BE49-F238E27FC236}">
-                <a16:creationId xmlns:a16="http://schemas.microsoft.com/office/drawing/2014/main" id="{3121D3B9-F70E-2E0C-C25D-BC0B5115634E}"/>
+                <a16:creationId xmlns:a16="http://schemas.microsoft.com/office/drawing/2014/main" id="{5C4A8934-3E30-617E-C2DD-165E83A300B1}"/>
               </a:ext>
             </a:extLst>
           </p:cNvPr>
@@ -7313,7 +9917,7 @@
             </a:lvl1pPr>
           </a:lstStyle>
           <a:p>
-            <a:fld id="{32B5C656-75F8-4A5E-8C6A-9C7AA7B5C5A4}" type="slidenum">
+            <a:fld id="{A60F9349-6CD5-4A62-B0BD-EE2AAB3C61D5}" type="slidenum">
               <a:rPr lang="en-US" smtClean="0"/>
               <a:t>‹#›</a:t>
             </a:fld>
@@ -7324,7 +9928,7 @@
     </p:spTree>
     <p:extLst>
       <p:ext uri="{BB962C8B-B14F-4D97-AF65-F5344CB8AC3E}">
-        <p14:creationId xmlns:p14="http://schemas.microsoft.com/office/powerpoint/2010/main" val="430013118"/>
+        <p14:creationId xmlns:p14="http://schemas.microsoft.com/office/powerpoint/2010/main" val="2070601880"/>
       </p:ext>
     </p:extLst>
   </p:cSld>
@@ -7647,7 +10251,7 @@
           <p:cNvPr id="2" name="scatter-chart">
             <a:extLst>
               <a:ext uri="{FF2B5EF4-FFF2-40B4-BE49-F238E27FC236}">
-                <a16:creationId xmlns:a16="http://schemas.microsoft.com/office/drawing/2014/main" id="{344BFF5F-CDD8-250A-6D33-E398A92C1DE8}"/>
+                <a16:creationId xmlns:a16="http://schemas.microsoft.com/office/drawing/2014/main" id="{BD2F7ECF-6259-F50F-59B5-7678BD030611}"/>
               </a:ext>
             </a:extLst>
           </p:cNvPr>
@@ -7655,7 +10259,7 @@
           <p:nvPr>
             <p:extLst>
               <p:ext uri="{D42A27DB-BD31-4B8C-83A1-F6EECF244321}">
-                <p14:modId xmlns:p14="http://schemas.microsoft.com/office/powerpoint/2010/main" val="2696664058"/>
+                <p14:modId xmlns:p14="http://schemas.microsoft.com/office/powerpoint/2010/main" val="1568560253"/>
               </p:ext>
             </p:extLst>
           </p:nvPr>
@@ -7673,7 +10277,7 @@
     </p:spTree>
     <p:extLst>
       <p:ext uri="{BB962C8B-B14F-4D97-AF65-F5344CB8AC3E}">
-        <p14:creationId xmlns:p14="http://schemas.microsoft.com/office/powerpoint/2010/main" val="3281935313"/>
+        <p14:creationId xmlns:p14="http://schemas.microsoft.com/office/powerpoint/2010/main" val="1534985918"/>
       </p:ext>
     </p:extLst>
   </p:cSld>
@@ -7705,7 +10309,7 @@
           <p:cNvPr id="2" name="bubble-chart">
             <a:extLst>
               <a:ext uri="{FF2B5EF4-FFF2-40B4-BE49-F238E27FC236}">
-                <a16:creationId xmlns:a16="http://schemas.microsoft.com/office/drawing/2014/main" id="{2AAAFF28-6374-161E-C567-091ACEAD791F}"/>
+                <a16:creationId xmlns:a16="http://schemas.microsoft.com/office/drawing/2014/main" id="{23204B95-20A0-5CAA-83C8-6125C53F82D4}"/>
               </a:ext>
             </a:extLst>
           </p:cNvPr>
@@ -7713,7 +10317,7 @@
           <p:nvPr>
             <p:extLst>
               <p:ext uri="{D42A27DB-BD31-4B8C-83A1-F6EECF244321}">
-                <p14:modId xmlns:p14="http://schemas.microsoft.com/office/powerpoint/2010/main" val="2566713583"/>
+                <p14:modId xmlns:p14="http://schemas.microsoft.com/office/powerpoint/2010/main" val="1330178917"/>
               </p:ext>
             </p:extLst>
           </p:nvPr>
@@ -7731,7 +10335,7 @@
     </p:spTree>
     <p:extLst>
       <p:ext uri="{BB962C8B-B14F-4D97-AF65-F5344CB8AC3E}">
-        <p14:creationId xmlns:p14="http://schemas.microsoft.com/office/powerpoint/2010/main" val="2924059268"/>
+        <p14:creationId xmlns:p14="http://schemas.microsoft.com/office/powerpoint/2010/main" val="4148657459"/>
       </p:ext>
     </p:extLst>
   </p:cSld>
@@ -7763,7 +10367,7 @@
           <p:cNvPr id="2" name="multilevel-bar-chart">
             <a:extLst>
               <a:ext uri="{FF2B5EF4-FFF2-40B4-BE49-F238E27FC236}">
-                <a16:creationId xmlns:a16="http://schemas.microsoft.com/office/drawing/2014/main" id="{4CE6B212-856B-690E-2ABD-C870B363810E}"/>
+                <a16:creationId xmlns:a16="http://schemas.microsoft.com/office/drawing/2014/main" id="{6AFC05F1-10BE-5600-AC87-395183C2A4E6}"/>
               </a:ext>
             </a:extLst>
           </p:cNvPr>
@@ -7771,7 +10375,7 @@
           <p:nvPr>
             <p:extLst>
               <p:ext uri="{D42A27DB-BD31-4B8C-83A1-F6EECF244321}">
-                <p14:modId xmlns:p14="http://schemas.microsoft.com/office/powerpoint/2010/main" val="1992804609"/>
+                <p14:modId xmlns:p14="http://schemas.microsoft.com/office/powerpoint/2010/main" val="112485497"/>
               </p:ext>
             </p:extLst>
           </p:nvPr>
@@ -7789,7 +10393,7 @@
     </p:spTree>
     <p:extLst>
       <p:ext uri="{BB962C8B-B14F-4D97-AF65-F5344CB8AC3E}">
-        <p14:creationId xmlns:p14="http://schemas.microsoft.com/office/powerpoint/2010/main" val="939053161"/>
+        <p14:creationId xmlns:p14="http://schemas.microsoft.com/office/powerpoint/2010/main" val="2562199935"/>
       </p:ext>
     </p:extLst>
   </p:cSld>
@@ -7821,7 +10425,7 @@
           <p:cNvPr id="2" name="pie-chart">
             <a:extLst>
               <a:ext uri="{FF2B5EF4-FFF2-40B4-BE49-F238E27FC236}">
-                <a16:creationId xmlns:a16="http://schemas.microsoft.com/office/drawing/2014/main" id="{96390454-1741-631C-7748-8C4CCD629FE8}"/>
+                <a16:creationId xmlns:a16="http://schemas.microsoft.com/office/drawing/2014/main" id="{C6B9228E-8326-6D72-68A1-9C6DF100024F}"/>
               </a:ext>
             </a:extLst>
           </p:cNvPr>
@@ -7829,7 +10433,7 @@
           <p:nvPr>
             <p:extLst>
               <p:ext uri="{D42A27DB-BD31-4B8C-83A1-F6EECF244321}">
-                <p14:modId xmlns:p14="http://schemas.microsoft.com/office/powerpoint/2010/main" val="166697705"/>
+                <p14:modId xmlns:p14="http://schemas.microsoft.com/office/powerpoint/2010/main" val="4227552853"/>
               </p:ext>
             </p:extLst>
           </p:nvPr>
@@ -7847,7 +10451,7 @@
     </p:spTree>
     <p:extLst>
       <p:ext uri="{BB962C8B-B14F-4D97-AF65-F5344CB8AC3E}">
-        <p14:creationId xmlns:p14="http://schemas.microsoft.com/office/powerpoint/2010/main" val="3757070597"/>
+        <p14:creationId xmlns:p14="http://schemas.microsoft.com/office/powerpoint/2010/main" val="1337859256"/>
       </p:ext>
     </p:extLst>
   </p:cSld>
@@ -7879,7 +10483,7 @@
           <p:cNvPr id="2" name="scatter-text-x-chart">
             <a:extLst>
               <a:ext uri="{FF2B5EF4-FFF2-40B4-BE49-F238E27FC236}">
-                <a16:creationId xmlns:a16="http://schemas.microsoft.com/office/drawing/2014/main" id="{8B271744-08A4-EA3C-064C-780D98E6D2E2}"/>
+                <a16:creationId xmlns:a16="http://schemas.microsoft.com/office/drawing/2014/main" id="{6C034F78-84D9-489D-1F2E-B160EA3DD639}"/>
               </a:ext>
             </a:extLst>
           </p:cNvPr>
@@ -7887,7 +10491,7 @@
           <p:nvPr>
             <p:extLst>
               <p:ext uri="{D42A27DB-BD31-4B8C-83A1-F6EECF244321}">
-                <p14:modId xmlns:p14="http://schemas.microsoft.com/office/powerpoint/2010/main" val="3813022660"/>
+                <p14:modId xmlns:p14="http://schemas.microsoft.com/office/powerpoint/2010/main" val="1066677338"/>
               </p:ext>
             </p:extLst>
           </p:nvPr>
@@ -7905,7 +10509,181 @@
     </p:spTree>
     <p:extLst>
       <p:ext uri="{BB962C8B-B14F-4D97-AF65-F5344CB8AC3E}">
-        <p14:creationId xmlns:p14="http://schemas.microsoft.com/office/powerpoint/2010/main" val="1277212851"/>
+        <p14:creationId xmlns:p14="http://schemas.microsoft.com/office/powerpoint/2010/main" val="3563280387"/>
+      </p:ext>
+    </p:extLst>
+  </p:cSld>
+  <p:clrMapOvr>
+    <a:masterClrMapping/>
+  </p:clrMapOvr>
+</p:sld>
+</file>
+
+<file path=ppt/slides/slide6.xml><?xml version="1.0" encoding="utf-8"?>
+<p:sld xmlns:a="http://schemas.openxmlformats.org/drawingml/2006/main" xmlns:r="http://schemas.openxmlformats.org/officeDocument/2006/relationships" xmlns:p="http://schemas.openxmlformats.org/presentationml/2006/main">
+  <p:cSld>
+    <p:spTree>
+      <p:nvGrpSpPr>
+        <p:cNvPr id="1" name=""/>
+        <p:cNvGrpSpPr/>
+        <p:nvPr/>
+      </p:nvGrpSpPr>
+      <p:grpSpPr>
+        <a:xfrm>
+          <a:off x="0" y="0"/>
+          <a:ext cx="0" cy="0"/>
+          <a:chOff x="0" y="0"/>
+          <a:chExt cx="0" cy="0"/>
+        </a:xfrm>
+      </p:grpSpPr>
+      <p:graphicFrame>
+        <p:nvGraphicFramePr>
+          <p:cNvPr id="2" name="bubble-text-x-chart">
+            <a:extLst>
+              <a:ext uri="{FF2B5EF4-FFF2-40B4-BE49-F238E27FC236}">
+                <a16:creationId xmlns:a16="http://schemas.microsoft.com/office/drawing/2014/main" id="{961C24E8-C14F-35A5-6322-89B4BF998C6A}"/>
+              </a:ext>
+            </a:extLst>
+          </p:cNvPr>
+          <p:cNvGraphicFramePr/>
+          <p:nvPr>
+            <p:extLst>
+              <p:ext uri="{D42A27DB-BD31-4B8C-83A1-F6EECF244321}">
+                <p14:modId xmlns:p14="http://schemas.microsoft.com/office/powerpoint/2010/main" val="2310139298"/>
+              </p:ext>
+            </p:extLst>
+          </p:nvPr>
+        </p:nvGraphicFramePr>
+        <p:xfrm>
+          <a:off x="762000" y="762000"/>
+          <a:ext cx="10668000" cy="5334000"/>
+        </p:xfrm>
+        <a:graphic>
+          <a:graphicData uri="http://schemas.openxmlformats.org/drawingml/2006/chart">
+            <c:chart xmlns:c="http://schemas.openxmlformats.org/drawingml/2006/chart" xmlns:r="http://schemas.openxmlformats.org/officeDocument/2006/relationships" r:id="rId2"/>
+          </a:graphicData>
+        </a:graphic>
+      </p:graphicFrame>
+    </p:spTree>
+    <p:extLst>
+      <p:ext uri="{BB962C8B-B14F-4D97-AF65-F5344CB8AC3E}">
+        <p14:creationId xmlns:p14="http://schemas.microsoft.com/office/powerpoint/2010/main" val="3171875012"/>
+      </p:ext>
+    </p:extLst>
+  </p:cSld>
+  <p:clrMapOvr>
+    <a:masterClrMapping/>
+  </p:clrMapOvr>
+</p:sld>
+</file>
+
+<file path=ppt/slides/slide7.xml><?xml version="1.0" encoding="utf-8"?>
+<p:sld xmlns:a="http://schemas.openxmlformats.org/drawingml/2006/main" xmlns:r="http://schemas.openxmlformats.org/officeDocument/2006/relationships" xmlns:p="http://schemas.openxmlformats.org/presentationml/2006/main">
+  <p:cSld>
+    <p:spTree>
+      <p:nvGrpSpPr>
+        <p:cNvPr id="1" name=""/>
+        <p:cNvGrpSpPr/>
+        <p:nvPr/>
+      </p:nvGrpSpPr>
+      <p:grpSpPr>
+        <a:xfrm>
+          <a:off x="0" y="0"/>
+          <a:ext cx="0" cy="0"/>
+          <a:chOff x="0" y="0"/>
+          <a:chExt cx="0" cy="0"/>
+        </a:xfrm>
+      </p:grpSpPr>
+      <p:graphicFrame>
+        <p:nvGraphicFramePr>
+          <p:cNvPr id="2" name="bubble-no-x-chart">
+            <a:extLst>
+              <a:ext uri="{FF2B5EF4-FFF2-40B4-BE49-F238E27FC236}">
+                <a16:creationId xmlns:a16="http://schemas.microsoft.com/office/drawing/2014/main" id="{F98BD7A6-1EBE-F244-A743-E4257A7EB0D3}"/>
+              </a:ext>
+            </a:extLst>
+          </p:cNvPr>
+          <p:cNvGraphicFramePr/>
+          <p:nvPr>
+            <p:extLst>
+              <p:ext uri="{D42A27DB-BD31-4B8C-83A1-F6EECF244321}">
+                <p14:modId xmlns:p14="http://schemas.microsoft.com/office/powerpoint/2010/main" val="383881141"/>
+              </p:ext>
+            </p:extLst>
+          </p:nvPr>
+        </p:nvGraphicFramePr>
+        <p:xfrm>
+          <a:off x="762000" y="762000"/>
+          <a:ext cx="10668000" cy="5334000"/>
+        </p:xfrm>
+        <a:graphic>
+          <a:graphicData uri="http://schemas.openxmlformats.org/drawingml/2006/chart">
+            <c:chart xmlns:c="http://schemas.openxmlformats.org/drawingml/2006/chart" xmlns:r="http://schemas.openxmlformats.org/officeDocument/2006/relationships" r:id="rId2"/>
+          </a:graphicData>
+        </a:graphic>
+      </p:graphicFrame>
+    </p:spTree>
+    <p:extLst>
+      <p:ext uri="{BB962C8B-B14F-4D97-AF65-F5344CB8AC3E}">
+        <p14:creationId xmlns:p14="http://schemas.microsoft.com/office/powerpoint/2010/main" val="732308727"/>
+      </p:ext>
+    </p:extLst>
+  </p:cSld>
+  <p:clrMapOvr>
+    <a:masterClrMapping/>
+  </p:clrMapOvr>
+</p:sld>
+</file>
+
+<file path=ppt/slides/slide8.xml><?xml version="1.0" encoding="utf-8"?>
+<p:sld xmlns:a="http://schemas.openxmlformats.org/drawingml/2006/main" xmlns:r="http://schemas.openxmlformats.org/officeDocument/2006/relationships" xmlns:p="http://schemas.openxmlformats.org/presentationml/2006/main">
+  <p:cSld>
+    <p:spTree>
+      <p:nvGrpSpPr>
+        <p:cNvPr id="1" name=""/>
+        <p:cNvGrpSpPr/>
+        <p:nvPr/>
+      </p:nvGrpSpPr>
+      <p:grpSpPr>
+        <a:xfrm>
+          <a:off x="0" y="0"/>
+          <a:ext cx="0" cy="0"/>
+          <a:chOff x="0" y="0"/>
+          <a:chExt cx="0" cy="0"/>
+        </a:xfrm>
+      </p:grpSpPr>
+      <p:graphicFrame>
+        <p:nvGraphicFramePr>
+          <p:cNvPr id="2" name="scatter-no-x-chart">
+            <a:extLst>
+              <a:ext uri="{FF2B5EF4-FFF2-40B4-BE49-F238E27FC236}">
+                <a16:creationId xmlns:a16="http://schemas.microsoft.com/office/drawing/2014/main" id="{A8DFE3FF-64D9-A655-6C01-D8312ECD9BF1}"/>
+              </a:ext>
+            </a:extLst>
+          </p:cNvPr>
+          <p:cNvGraphicFramePr/>
+          <p:nvPr>
+            <p:extLst>
+              <p:ext uri="{D42A27DB-BD31-4B8C-83A1-F6EECF244321}">
+                <p14:modId xmlns:p14="http://schemas.microsoft.com/office/powerpoint/2010/main" val="45418021"/>
+              </p:ext>
+            </p:extLst>
+          </p:nvPr>
+        </p:nvGraphicFramePr>
+        <p:xfrm>
+          <a:off x="762000" y="762000"/>
+          <a:ext cx="10668000" cy="5334000"/>
+        </p:xfrm>
+        <a:graphic>
+          <a:graphicData uri="http://schemas.openxmlformats.org/drawingml/2006/chart">
+            <c:chart xmlns:c="http://schemas.openxmlformats.org/drawingml/2006/chart" xmlns:r="http://schemas.openxmlformats.org/officeDocument/2006/relationships" r:id="rId2"/>
+          </a:graphicData>
+        </a:graphic>
+      </p:graphicFrame>
+    </p:spTree>
+    <p:extLst>
+      <p:ext uri="{BB962C8B-B14F-4D97-AF65-F5344CB8AC3E}">
+        <p14:creationId xmlns:p14="http://schemas.microsoft.com/office/powerpoint/2010/main" val="556677852"/>
       </p:ext>
     </p:extLst>
   </p:cSld>

</xml_diff>